<commit_message>
Use rupees only: replace USD market figure and INR labels with ₹
Co-Authored-By: Claude Sonnet 5.5 <noreply@anthropic.com>
Claude-Session: https://claude.ai/code/session_01WaQ68i8weamWtZdtHKnsBS
</commit_message>
<xml_diff>
--- a/pitch/WedVerse_AI_Shark_Tank_Pitch.pptx
+++ b/pitch/WedVerse_AI_Shark_Tank_Pitch.pptx
@@ -119,38 +119,38 @@
   <p:extLst>
     <p:ext uri="{521415D9-36F7-43E2-AB2F-B90AF26B5E84}">
       <p14:sectionLst xmlns:p14="http://schemas.microsoft.com/office/powerpoint/2010/main">
-        <p14:section name="Opening" id="{717b5cf4-5bc0-2185-1e3e-7b55e69a20a7}">
+        <p14:section name="Opening" id="{e51f670c-6e0d-7f15-cc0f-e69259c61286}">
           <p14:sldIdLst>
             <p14:sldId id="256"/>
             <p14:sldId id="257"/>
           </p14:sldIdLst>
         </p14:section>
-        <p14:section name="Problem &amp; Solution" id="{720318f0-7703-13cc-c4f0-578cbcd08dbe}">
+        <p14:section name="Problem &amp; Solution" id="{4d50eb0f-153e-fed6-5f7d-3a7e8ca8c4c3}">
           <p14:sldIdLst>
             <p14:sldId id="258"/>
             <p14:sldId id="259"/>
           </p14:sldIdLst>
         </p14:section>
-        <p14:section name="Product" id="{50741608-8431-f3d5-1a6b-a8eb35e09ff9}">
+        <p14:section name="Product" id="{56b064a0-a1c0-382a-aaf1-5daeb64e6a14}">
           <p14:sldIdLst>
             <p14:sldId id="260"/>
             <p14:sldId id="261"/>
           </p14:sldIdLst>
         </p14:section>
-        <p14:section name="Market &amp; Model" id="{53ae1097-eb4f-56d4-b34e-2aef5af02f4c}">
+        <p14:section name="Market &amp; Model" id="{03384425-1dd0-5a07-316b-b31a40b31885}">
           <p14:sldIdLst>
             <p14:sldId id="262"/>
             <p14:sldId id="263"/>
           </p14:sldIdLst>
         </p14:section>
-        <p14:section name="Edge &amp; Growth" id="{8865a272-99ac-cf5c-bbfa-6f7b5d46efd1}">
+        <p14:section name="Edge &amp; Growth" id="{2980292e-3ff9-7e03-7d9f-06071c9d1f71}">
           <p14:sldIdLst>
             <p14:sldId id="264"/>
             <p14:sldId id="265"/>
             <p14:sldId id="266"/>
           </p14:sldIdLst>
         </p14:section>
-        <p14:section name="The Ask" id="{af7afeed-b30a-c732-cbfc-0693db08f3dc}">
+        <p14:section name="The Ask" id="{a498a8ed-686e-95e5-b22e-2e7a5d6e2b22}">
           <p14:sldIdLst>
             <p14:sldId id="267"/>
             <p14:sldId id="268"/>
@@ -7905,7 +7905,7 @@
         <p:spPr>
           <a:xfrm>
             <a:off x="777240" y="1508760"/>
-            <a:ext cx="2194560" cy="868680"/>
+            <a:ext cx="2286000" cy="868680"/>
           </a:xfrm>
           <a:prstGeom prst="rect">
             <a:avLst/>
@@ -7921,7 +7921,7 @@
               <a:buNone/>
             </a:pPr>
             <a:r>
-              <a:rPr lang="en-US" sz="4600" b="1" dirty="0">
+              <a:rPr lang="en-US" sz="3600" b="1" dirty="0">
                 <a:solidFill>
                   <a:srgbClr val="5B52E0"/>
                 </a:solidFill>
@@ -7931,7 +7931,7 @@
               </a:rPr>
               <a:t>~10M</a:t>
             </a:r>
-            <a:endParaRPr lang="en-US" sz="4600" dirty="0"/>
+            <a:endParaRPr lang="en-US" sz="3600" dirty="0"/>
           </a:p>
         </p:txBody>
       </p:sp>
@@ -8017,7 +8017,7 @@
         <p:spPr>
           <a:xfrm>
             <a:off x="3520440" y="1508760"/>
-            <a:ext cx="2194560" cy="868680"/>
+            <a:ext cx="2286000" cy="868680"/>
           </a:xfrm>
           <a:prstGeom prst="rect">
             <a:avLst/>
@@ -8033,7 +8033,7 @@
               <a:buNone/>
             </a:pPr>
             <a:r>
-              <a:rPr lang="en-US" sz="4600" b="1" dirty="0">
+              <a:rPr lang="en-US" sz="3600" b="1" dirty="0">
                 <a:solidFill>
                   <a:srgbClr val="B98A2E"/>
                 </a:solidFill>
@@ -8041,9 +8041,9 @@
                 <a:ea typeface="Cambria" pitchFamily="34" charset="-122"/>
                 <a:cs typeface="Cambria" pitchFamily="34" charset="-120"/>
               </a:rPr>
-              <a:t>~$130B</a:t>
+              <a:t>~₹10L Cr</a:t>
             </a:r>
-            <a:endParaRPr lang="en-US" sz="4600" dirty="0"/>
+            <a:endParaRPr lang="en-US" sz="3600" dirty="0"/>
           </a:p>
         </p:txBody>
       </p:sp>
@@ -8080,7 +8080,7 @@
                 <a:ea typeface="Calibri" pitchFamily="34" charset="-122"/>
                 <a:cs typeface="Calibri" pitchFamily="34" charset="-120"/>
               </a:rPr>
-              <a:t>estimated annual wedding spend</a:t>
+              <a:t>estimated annual wedding spend (₹10 lakh crore)</a:t>
             </a:r>
             <a:endParaRPr lang="en-US" sz="1500" dirty="0"/>
           </a:p>
@@ -8129,7 +8129,7 @@
         <p:spPr>
           <a:xfrm>
             <a:off x="6263640" y="1508760"/>
-            <a:ext cx="2194560" cy="868680"/>
+            <a:ext cx="2286000" cy="868680"/>
           </a:xfrm>
           <a:prstGeom prst="rect">
             <a:avLst/>
@@ -8145,7 +8145,7 @@
               <a:buNone/>
             </a:pPr>
             <a:r>
-              <a:rPr lang="en-US" sz="4600" b="1" dirty="0">
+              <a:rPr lang="en-US" sz="3600" b="1" dirty="0">
                 <a:solidFill>
                   <a:srgbClr val="3AA68A"/>
                 </a:solidFill>
@@ -8155,7 +8155,7 @@
               </a:rPr>
               <a:t>10–15%</a:t>
             </a:r>
-            <a:endParaRPr lang="en-US" sz="4600" dirty="0"/>
+            <a:endParaRPr lang="en-US" sz="3600" dirty="0"/>
           </a:p>
         </p:txBody>
       </p:sp>

</xml_diff>

<commit_message>
Pitch deck polish: calmer background, stronger text contrast, cleaner closing slide
Co-Authored-By: Claude Sonnet 5.5 <noreply@anthropic.com>
Claude-Session: https://claude.ai/code/session_01WaQ68i8weamWtZdtHKnsBS
</commit_message>
<xml_diff>
--- a/pitch/WedVerse_AI_Shark_Tank_Pitch.pptx
+++ b/pitch/WedVerse_AI_Shark_Tank_Pitch.pptx
@@ -119,38 +119,38 @@
   <p:extLst>
     <p:ext uri="{521415D9-36F7-43E2-AB2F-B90AF26B5E84}">
       <p14:sectionLst xmlns:p14="http://schemas.microsoft.com/office/powerpoint/2010/main">
-        <p14:section name="Opening" id="{e51f670c-6e0d-7f15-cc0f-e69259c61286}">
+        <p14:section name="Opening" id="{c5fed69b-6379-d587-07a0-d485c4826fa3}">
           <p14:sldIdLst>
             <p14:sldId id="256"/>
             <p14:sldId id="257"/>
           </p14:sldIdLst>
         </p14:section>
-        <p14:section name="Problem &amp; Solution" id="{4d50eb0f-153e-fed6-5f7d-3a7e8ca8c4c3}">
+        <p14:section name="Problem &amp; Solution" id="{decbe227-3909-e0a9-f703-acf00cd15cca}">
           <p14:sldIdLst>
             <p14:sldId id="258"/>
             <p14:sldId id="259"/>
           </p14:sldIdLst>
         </p14:section>
-        <p14:section name="Product" id="{56b064a0-a1c0-382a-aaf1-5daeb64e6a14}">
+        <p14:section name="Product" id="{d15f995b-aeb5-cf31-46ee-7fbfd305fc28}">
           <p14:sldIdLst>
             <p14:sldId id="260"/>
             <p14:sldId id="261"/>
           </p14:sldIdLst>
         </p14:section>
-        <p14:section name="Market &amp; Model" id="{03384425-1dd0-5a07-316b-b31a40b31885}">
+        <p14:section name="Market &amp; Model" id="{11aa6506-67b3-2ecd-2ea2-091b208ded91}">
           <p14:sldIdLst>
             <p14:sldId id="262"/>
             <p14:sldId id="263"/>
           </p14:sldIdLst>
         </p14:section>
-        <p14:section name="Edge &amp; Growth" id="{2980292e-3ff9-7e03-7d9f-06071c9d1f71}">
+        <p14:section name="Edge &amp; Growth" id="{c0072c16-e55a-abbe-7cc0-75b93698f60a}">
           <p14:sldIdLst>
             <p14:sldId id="264"/>
             <p14:sldId id="265"/>
             <p14:sldId id="266"/>
           </p14:sldIdLst>
         </p14:section>
-        <p14:section name="The Ask" id="{a498a8ed-686e-95e5-b22e-2e7a5d6e2b22}">
+        <p14:section name="The Ask" id="{84b8338d-cdc7-292f-2cd7-3a9838425bb2}">
           <p14:sldIdLst>
             <p14:sldId id="267"/>
             <p14:sldId id="268"/>
@@ -181,7 +181,7 @@
                 <a:solidFill>
                   <a:srgbClr val="1B1033"/>
                 </a:solidFill>
-                <a:latin typeface="Arial"/>
+                <a:latin typeface="+mn-lt"/>
               </a:defRPr>
             </a:pPr>
             <a:r>
@@ -189,7 +189,7 @@
                 <a:solidFill>
                   <a:srgbClr val="1B1033"/>
                 </a:solidFill>
-                <a:latin typeface="Arial"/>
+                <a:latin typeface="+mn-lt"/>
               </a:rPr>
               <a:t>Revenue (₹ Cr) — illustrative</a:t>
             </a:r>
@@ -439,7 +439,7 @@
                 <a:solidFill>
                   <a:srgbClr val="FFFFFF"/>
                 </a:solidFill>
-                <a:latin typeface="Arial"/>
+                <a:latin typeface="+mn-lt"/>
               </a:defRPr>
             </a:pPr>
             <a:r>
@@ -447,7 +447,7 @@
                 <a:solidFill>
                   <a:srgbClr val="FFFFFF"/>
                 </a:solidFill>
-                <a:latin typeface="Arial"/>
+                <a:latin typeface="+mn-lt"/>
               </a:rPr>
               <a:t>Use of funds</a:t>
             </a:r>
@@ -4770,7 +4770,24 @@
                 <a:ea typeface="Cambria" pitchFamily="34" charset="-122"/>
                 <a:cs typeface="Cambria" pitchFamily="34" charset="-120"/>
               </a:rPr>
-              <a:t>Let's make every wedding a masterpiece</a:t>
+              <a:t>Let's make every wedding</a:t>
+            </a:r>
+            <a:endParaRPr lang="en-US" sz="4600" dirty="0"/>
+          </a:p>
+          <a:p>
+            <a:pPr algn="ctr" indent="0" marL="0">
+              <a:buNone/>
+            </a:pPr>
+            <a:r>
+              <a:rPr lang="en-US" sz="4600" b="1" dirty="0">
+                <a:solidFill>
+                  <a:srgbClr val="FFFFFF"/>
+                </a:solidFill>
+                <a:latin typeface="Cambria" pitchFamily="34" charset="0"/>
+                <a:ea typeface="Cambria" pitchFamily="34" charset="-122"/>
+                <a:cs typeface="Cambria" pitchFamily="34" charset="-120"/>
+              </a:rPr>
+              <a:t>a masterpiece</a:t>
             </a:r>
             <a:endParaRPr lang="en-US" sz="4600" dirty="0"/>
           </a:p>
@@ -6972,8 +6989,8 @@
         </p:nvSpPr>
         <p:spPr>
           <a:xfrm>
-            <a:off x="548640" y="4297680"/>
-            <a:ext cx="4663440" cy="320040"/>
+            <a:off x="548640" y="4480560"/>
+            <a:ext cx="4663440" cy="274320"/>
           </a:xfrm>
           <a:prstGeom prst="rect">
             <a:avLst/>
@@ -6997,7 +7014,7 @@
                 <a:ea typeface="Calibri" pitchFamily="34" charset="-122"/>
                 <a:cs typeface="Calibri" pitchFamily="34" charset="-120"/>
               </a:rPr>
-              <a:t>← Live 3D preview · drag, zoom, walk the aisle</a:t>
+              <a:t>Live 3D preview — drag, zoom, walk the aisle</a:t>
             </a:r>
             <a:endParaRPr lang="en-US" sz="1400" dirty="0"/>
           </a:p>

</xml_diff>

<commit_message>
Pitch deck: remove 3D renders and app screenshots; use icons, shapes and palettes only
Co-Authored-By: Claude Sonnet 5.5 <noreply@anthropic.com>
Claude-Session: https://claude.ai/code/session_01WaQ68i8weamWtZdtHKnsBS
</commit_message>
<xml_diff>
--- a/pitch/WedVerse_AI_Shark_Tank_Pitch.pptx
+++ b/pitch/WedVerse_AI_Shark_Tank_Pitch.pptx
@@ -119,38 +119,38 @@
   <p:extLst>
     <p:ext uri="{521415D9-36F7-43E2-AB2F-B90AF26B5E84}">
       <p14:sectionLst xmlns:p14="http://schemas.microsoft.com/office/powerpoint/2010/main">
-        <p14:section name="Opening" id="{c5fed69b-6379-d587-07a0-d485c4826fa3}">
+        <p14:section name="Opening" id="{ba8de646-a078-af78-a631-00a683ab6bff}">
           <p14:sldIdLst>
             <p14:sldId id="256"/>
             <p14:sldId id="257"/>
           </p14:sldIdLst>
         </p14:section>
-        <p14:section name="Problem &amp; Solution" id="{decbe227-3909-e0a9-f703-acf00cd15cca}">
+        <p14:section name="Problem &amp; Solution" id="{2525e38f-18b1-84f2-accc-a958a5d9d3e5}">
           <p14:sldIdLst>
             <p14:sldId id="258"/>
             <p14:sldId id="259"/>
           </p14:sldIdLst>
         </p14:section>
-        <p14:section name="Product" id="{d15f995b-aeb5-cf31-46ee-7fbfd305fc28}">
+        <p14:section name="Product" id="{ed2f10d3-5201-edf8-3bd4-bef29319a55b}">
           <p14:sldIdLst>
             <p14:sldId id="260"/>
             <p14:sldId id="261"/>
           </p14:sldIdLst>
         </p14:section>
-        <p14:section name="Market &amp; Model" id="{11aa6506-67b3-2ecd-2ea2-091b208ded91}">
+        <p14:section name="Market &amp; Model" id="{fa7d15f3-866c-9c56-c3fd-c35d3b2f01f1}">
           <p14:sldIdLst>
             <p14:sldId id="262"/>
             <p14:sldId id="263"/>
           </p14:sldIdLst>
         </p14:section>
-        <p14:section name="Edge &amp; Growth" id="{c0072c16-e55a-abbe-7cc0-75b93698f60a}">
+        <p14:section name="Edge &amp; Growth" id="{eee94041-73f6-4750-1d43-72485b28be14}">
           <p14:sldIdLst>
             <p14:sldId id="264"/>
             <p14:sldId id="265"/>
             <p14:sldId id="266"/>
           </p14:sldIdLst>
         </p14:section>
-        <p14:section name="The Ask" id="{84b8338d-cdc7-292f-2cd7-3a9838425bb2}">
+        <p14:section name="The Ask" id="{c60e51b7-969d-a6c8-3758-8934c43d9594}">
           <p14:sldIdLst>
             <p14:sldId id="267"/>
             <p14:sldId id="268"/>
@@ -1516,7 +1516,7 @@
           <a:p>
             <a:r>
               <a:rPr lang="en-US" dirty="0"/>
-              <a:t>Close with eye contact. Then Q&amp;A. Prep: CAC, pricing proof, why now (3D in browser + AI), defensibility, founder-market fit.</a:t>
+              <a:t>Close with eye contact. Then Q&amp;A. Prep: CAC, pricing proof, why now (browser-based visualisation + AI), defensibility, founder-market fit.</a:t>
             </a:r>
             <a:endParaRPr lang="en-US" dirty="0"/>
           </a:p>
@@ -1868,7 +1868,7 @@
           <a:p>
             <a:r>
               <a:rPr lang="en-US" dirty="0"/>
-              <a:t>DEMO (45 sec): open index.html. Switch theme live, drag guests to 700 to trigger the capacity warning, open Quote. Say: "Every number you see updates from what is in the 3D scene."</a:t>
+              <a:t>DEMO (45 sec): open index.html. Switch theme live, drag guests to 700 to trigger the capacity warning, open Quote. Say: "Every number you see updates from what is in the scene."</a:t>
             </a:r>
             <a:endParaRPr lang="en-US" dirty="0"/>
           </a:p>
@@ -1956,7 +1956,7 @@
           <a:p>
             <a:r>
               <a:rPr lang="en-US" dirty="0"/>
-              <a:t>Click through the four themes live. This is the "wow": the couple argues about colours in minutes, not weeks.</a:t>
+              <a:t>Couples argue about colours for weeks. With WedVerse they compare four complete looks in minutes.</a:t>
             </a:r>
             <a:endParaRPr lang="en-US" dirty="0"/>
           </a:p>
@@ -2801,64 +2801,88 @@
           <a:chExt cx="0" cy="0"/>
         </a:xfrm>
       </p:grpSpPr>
-      <p:pic>
-        <p:nvPicPr>
-          <p:cNvPr id="2" name="hero-3d" descr="3D preview of a decorated wedding hall">    </p:cNvPr>
-          <p:cNvPicPr>
-            <a:picLocks noChangeAspect="1"/>
-          </p:cNvPicPr>
-          <p:nvPr/>
-        </p:nvPicPr>
-        <p:blipFill>
-          <a:blip r:embed="rId1"/>
-          <a:stretch>
-            <a:fillRect/>
-          </a:stretch>
-        </p:blipFill>
-        <p:spPr>
-          <a:xfrm>
-            <a:off x="0" y="0"/>
-            <a:ext cx="9144000" cy="5143500"/>
-          </a:xfrm>
-          <a:prstGeom prst="rect">
-            <a:avLst/>
-          </a:prstGeom>
-        </p:spPr>
-      </p:pic>
-      <p:pic>
-        <p:nvPicPr>
-          <p:cNvPr id="3" name="hero-fade" descr="img/ov-left.png">    </p:cNvPr>
-          <p:cNvPicPr>
-            <a:picLocks noChangeAspect="1"/>
-          </p:cNvPicPr>
-          <p:nvPr/>
-        </p:nvPicPr>
-        <p:blipFill>
-          <a:blip r:embed="rId2"/>
-          <a:stretch>
-            <a:fillRect/>
-          </a:stretch>
-        </p:blipFill>
-        <p:spPr>
-          <a:xfrm>
-            <a:off x="0" y="0"/>
-            <a:ext cx="9144000" cy="5143500"/>
-          </a:xfrm>
-          <a:prstGeom prst="rect">
-            <a:avLst/>
-          </a:prstGeom>
-        </p:spPr>
-      </p:pic>
-      <p:sp>
-        <p:nvSpPr>
-          <p:cNvPr id="4" name="logo-bg"/>
+      <p:sp>
+        <p:nvSpPr>
+          <p:cNvPr id="2" name="ring-4.6"/>
           <p:cNvSpPr/>
           <p:nvPr/>
         </p:nvSpPr>
         <p:spPr>
           <a:xfrm>
-            <a:off x="548640" y="502920"/>
-            <a:ext cx="457200" cy="457200"/>
+            <a:off x="4480560" y="457200"/>
+            <a:ext cx="4206240" cy="4206240"/>
+          </a:xfrm>
+          <a:prstGeom prst="ellipse">
+            <a:avLst/>
+          </a:prstGeom>
+          <a:ln w="12700">
+            <a:solidFill>
+              <a:srgbClr val="E9C978">
+                <a:alpha val="18000"/>
+              </a:srgbClr>
+            </a:solidFill>
+            <a:prstDash val="solid"/>
+          </a:ln>
+        </p:spPr>
+      </p:sp>
+      <p:sp>
+        <p:nvSpPr>
+          <p:cNvPr id="3" name="ring-3.4"/>
+          <p:cNvSpPr/>
+          <p:nvPr/>
+        </p:nvSpPr>
+        <p:spPr>
+          <a:xfrm>
+            <a:off x="5029200" y="1005840"/>
+            <a:ext cx="3108960" cy="3108960"/>
+          </a:xfrm>
+          <a:prstGeom prst="ellipse">
+            <a:avLst/>
+          </a:prstGeom>
+          <a:ln w="12700">
+            <a:solidFill>
+              <a:srgbClr val="E9C978">
+                <a:alpha val="30000"/>
+              </a:srgbClr>
+            </a:solidFill>
+            <a:prstDash val="solid"/>
+          </a:ln>
+        </p:spPr>
+      </p:sp>
+      <p:sp>
+        <p:nvSpPr>
+          <p:cNvPr id="4" name="ring-2.2"/>
+          <p:cNvSpPr/>
+          <p:nvPr/>
+        </p:nvSpPr>
+        <p:spPr>
+          <a:xfrm>
+            <a:off x="5577840" y="1554480"/>
+            <a:ext cx="2011680" cy="2011680"/>
+          </a:xfrm>
+          <a:prstGeom prst="ellipse">
+            <a:avLst/>
+          </a:prstGeom>
+          <a:ln w="12700">
+            <a:solidFill>
+              <a:srgbClr val="E9C978">
+                <a:alpha val="45000"/>
+              </a:srgbClr>
+            </a:solidFill>
+            <a:prstDash val="solid"/>
+          </a:ln>
+        </p:spPr>
+      </p:sp>
+      <p:sp>
+        <p:nvSpPr>
+          <p:cNvPr id="5" name="hero-core"/>
+          <p:cNvSpPr/>
+          <p:nvPr/>
+        </p:nvSpPr>
+        <p:spPr>
+          <a:xfrm>
+            <a:off x="6035040" y="2011680"/>
+            <a:ext cx="1097280" cy="1097280"/>
           </a:xfrm>
           <a:prstGeom prst="ellipse">
             <a:avLst/>
@@ -2872,18 +2896,25 @@
             </a:solidFill>
             <a:prstDash val="solid"/>
           </a:ln>
-        </p:spPr>
-      </p:sp>
-      <p:sp>
-        <p:nvSpPr>
-          <p:cNvPr id="5" name="Text 1"/>
+          <a:effectLst>
+            <a:outerShdw sx="100000" sy="100000" kx="0" ky="0" algn="bl" rotWithShape="0" blurRad="304800" dist="50800" dir="5400000">
+              <a:srgbClr val="E9C978">
+                <a:alpha val="45000"/>
+              </a:srgbClr>
+            </a:outerShdw>
+          </a:effectLst>
+        </p:spPr>
+      </p:sp>
+      <p:sp>
+        <p:nvSpPr>
+          <p:cNvPr id="6" name="Text 4"/>
           <p:cNvSpPr txBox="1"/>
           <p:nvPr/>
         </p:nvSpPr>
         <p:spPr>
           <a:xfrm>
-            <a:off x="548640" y="502920"/>
-            <a:ext cx="457200" cy="457200"/>
+            <a:off x="6035040" y="2011680"/>
+            <a:ext cx="1097280" cy="1097280"/>
           </a:xfrm>
           <a:prstGeom prst="rect">
             <a:avLst/>
@@ -2899,7 +2930,7 @@
               <a:buNone/>
             </a:pPr>
             <a:r>
-              <a:rPr lang="en-US" sz="1800" b="1" dirty="0">
+              <a:rPr lang="en-US" sz="4400" b="1" dirty="0">
                 <a:solidFill>
                   <a:srgbClr val="1B1033"/>
                 </a:solidFill>
@@ -2909,198 +2940,219 @@
               </a:rPr>
               <a:t>✦</a:t>
             </a:r>
-            <a:endParaRPr lang="en-US" sz="1800" dirty="0"/>
-          </a:p>
-        </p:txBody>
-      </p:sp>
-      <p:sp>
-        <p:nvSpPr>
-          <p:cNvPr id="6" name="Text 2"/>
-          <p:cNvSpPr txBox="1"/>
-          <p:nvPr/>
-        </p:nvSpPr>
-        <p:spPr>
-          <a:xfrm>
-            <a:off x="1097280" y="502920"/>
-            <a:ext cx="2286000" cy="457200"/>
-          </a:xfrm>
-          <a:prstGeom prst="rect">
-            <a:avLst/>
-          </a:prstGeom>
-          <a:noFill/>
-          <a:ln/>
-        </p:spPr>
-        <p:txBody>
-          <a:bodyPr wrap="square" lIns="0" tIns="0" rIns="0" bIns="0" rtlCol="0" anchor="ctr"/>
-          <a:lstStyle/>
-          <a:p>
-            <a:pPr indent="0" marL="0">
-              <a:buNone/>
-            </a:pPr>
-            <a:r>
-              <a:rPr lang="en-US" sz="1300" b="1" spc="600" kern="0" dirty="0">
-                <a:solidFill>
-                  <a:srgbClr val="FFFFFF"/>
-                </a:solidFill>
-                <a:latin typeface="Calibri" pitchFamily="34" charset="0"/>
-                <a:ea typeface="Calibri" pitchFamily="34" charset="-122"/>
-                <a:cs typeface="Calibri" pitchFamily="34" charset="-120"/>
-              </a:rPr>
-              <a:t>WEDVERSE</a:t>
-            </a:r>
-            <a:endParaRPr lang="en-US" sz="1300" dirty="0"/>
-          </a:p>
-        </p:txBody>
-      </p:sp>
-      <p:sp>
-        <p:nvSpPr>
-          <p:cNvPr id="7" name="Text 3"/>
-          <p:cNvSpPr txBox="1"/>
-          <p:nvPr/>
-        </p:nvSpPr>
-        <p:spPr>
-          <a:xfrm>
-            <a:off x="548640" y="1554480"/>
-            <a:ext cx="4572000" cy="274320"/>
-          </a:xfrm>
-          <a:prstGeom prst="rect">
-            <a:avLst/>
-          </a:prstGeom>
-          <a:noFill/>
-          <a:ln/>
-        </p:spPr>
-        <p:txBody>
-          <a:bodyPr wrap="square" lIns="0" tIns="0" rIns="0" bIns="0" rtlCol="0" anchor="ctr"/>
-          <a:lstStyle/>
-          <a:p>
-            <a:pPr indent="0" marL="0">
-              <a:buNone/>
-            </a:pPr>
-            <a:r>
-              <a:rPr lang="en-US" sz="1200" b="1" spc="500" kern="0" dirty="0">
-                <a:solidFill>
-                  <a:srgbClr val="E9C978"/>
-                </a:solidFill>
-                <a:latin typeface="Calibri" pitchFamily="34" charset="0"/>
-                <a:ea typeface="Calibri" pitchFamily="34" charset="-122"/>
-                <a:cs typeface="Calibri" pitchFamily="34" charset="-120"/>
-              </a:rPr>
-              <a:t>PLAN · VISUALIZE · CELEBRATE</a:t>
-            </a:r>
-            <a:endParaRPr lang="en-US" sz="1200" dirty="0"/>
-          </a:p>
-        </p:txBody>
-      </p:sp>
-      <p:sp>
-        <p:nvSpPr>
-          <p:cNvPr id="8" name="Text 4"/>
+            <a:endParaRPr lang="en-US" sz="4400" dirty="0"/>
+          </a:p>
+        </p:txBody>
+      </p:sp>
+      <p:sp>
+        <p:nvSpPr>
+          <p:cNvPr id="7" name="icon-bg-orb-FaRupeeSign"/>
           <p:cNvSpPr/>
           <p:nvPr/>
         </p:nvSpPr>
         <p:spPr>
           <a:xfrm>
-            <a:off x="548640" y="1828800"/>
-            <a:ext cx="5486400" cy="1005840"/>
-          </a:xfrm>
-          <a:prstGeom prst="rect">
-            <a:avLst/>
-          </a:prstGeom>
-          <a:noFill/>
-          <a:ln/>
-        </p:spPr>
-        <p:txBody>
-          <a:bodyPr wrap="square" lIns="0" tIns="0" rIns="0" bIns="0" rtlCol="0" anchor="t"/>
-          <a:lstStyle/>
-          <a:p>
-            <a:pPr indent="0" marL="0">
-              <a:buNone/>
-            </a:pPr>
-            <a:r>
-              <a:rPr lang="en-US" sz="6400" b="1" dirty="0">
-                <a:solidFill>
-                  <a:srgbClr val="FFFFFF"/>
-                </a:solidFill>
-                <a:latin typeface="Cambria" pitchFamily="34" charset="0"/>
-                <a:ea typeface="Cambria" pitchFamily="34" charset="-122"/>
-                <a:cs typeface="Cambria" pitchFamily="34" charset="-120"/>
-              </a:rPr>
-              <a:t>WedVerse AI</a:t>
-            </a:r>
-            <a:endParaRPr lang="en-US" sz="6400" dirty="0"/>
-          </a:p>
-        </p:txBody>
-      </p:sp>
-      <p:sp>
-        <p:nvSpPr>
-          <p:cNvPr id="9" name="Text 5"/>
-          <p:cNvSpPr txBox="1"/>
-          <p:nvPr/>
-        </p:nvSpPr>
-        <p:spPr>
-          <a:xfrm>
-            <a:off x="548640" y="2880360"/>
-            <a:ext cx="4754880" cy="914400"/>
-          </a:xfrm>
-          <a:prstGeom prst="rect">
-            <a:avLst/>
-          </a:prstGeom>
-          <a:noFill/>
-          <a:ln/>
-        </p:spPr>
-        <p:txBody>
-          <a:bodyPr wrap="square" lIns="0" tIns="0" rIns="0" bIns="0" rtlCol="0" anchor="t"/>
-          <a:lstStyle/>
-          <a:p>
-            <a:pPr indent="0" marL="0">
-              <a:buNone/>
-            </a:pPr>
-            <a:r>
-              <a:rPr lang="en-US" sz="2600" i="1" dirty="0">
-                <a:solidFill>
-                  <a:srgbClr val="FFFFFF"/>
-                </a:solidFill>
-                <a:latin typeface="Cambria" pitchFamily="34" charset="0"/>
-                <a:ea typeface="Cambria" pitchFamily="34" charset="-122"/>
-                <a:cs typeface="Cambria" pitchFamily="34" charset="-120"/>
-              </a:rPr>
-              <a:t>See your wedding before</a:t>
-            </a:r>
-            <a:endParaRPr lang="en-US" sz="2600" dirty="0"/>
-          </a:p>
-          <a:p>
-            <a:pPr indent="0" marL="0">
-              <a:buNone/>
-            </a:pPr>
-            <a:r>
-              <a:rPr lang="en-US" sz="2600" i="1" dirty="0">
-                <a:solidFill>
-                  <a:srgbClr val="FFFFFF"/>
-                </a:solidFill>
-                <a:latin typeface="Cambria" pitchFamily="34" charset="0"/>
-                <a:ea typeface="Cambria" pitchFamily="34" charset="-122"/>
-                <a:cs typeface="Cambria" pitchFamily="34" charset="-120"/>
-              </a:rPr>
-              <a:t>you spend on it.</a:t>
-            </a:r>
-            <a:endParaRPr lang="en-US" sz="2600" dirty="0"/>
-          </a:p>
-        </p:txBody>
-      </p:sp>
-      <p:sp>
-        <p:nvSpPr>
-          <p:cNvPr id="10" name="ask-pill"/>
+            <a:off x="7818120" y="1143000"/>
+            <a:ext cx="640080" cy="640080"/>
+          </a:xfrm>
+          <a:prstGeom prst="ellipse">
+            <a:avLst/>
+          </a:prstGeom>
+          <a:solidFill>
+            <a:srgbClr val="5B52E0"/>
+          </a:solidFill>
+          <a:ln w="12700">
+            <a:solidFill>
+              <a:srgbClr val="5B52E0"/>
+            </a:solidFill>
+            <a:prstDash val="solid"/>
+          </a:ln>
+        </p:spPr>
+      </p:sp>
+      <p:pic>
+        <p:nvPicPr>
+          <p:cNvPr id="8" name="icon-orb-FaRupeeSign" descr="orb-FaRupeeSign">    </p:cNvPr>
+          <p:cNvPicPr>
+            <a:picLocks noChangeAspect="1"/>
+          </p:cNvPicPr>
+          <p:nvPr/>
+        </p:nvPicPr>
+        <p:blipFill>
+          <a:blip r:embed="rId1"/>
+          <a:stretch>
+            <a:fillRect/>
+          </a:stretch>
+        </p:blipFill>
+        <p:spPr>
+          <a:xfrm>
+            <a:off x="7990942" y="1315822"/>
+            <a:ext cx="294437" cy="294437"/>
+          </a:xfrm>
+          <a:prstGeom prst="rect">
+            <a:avLst/>
+          </a:prstGeom>
+        </p:spPr>
+      </p:pic>
+      <p:sp>
+        <p:nvSpPr>
+          <p:cNvPr id="9" name="icon-bg-orb-FaPalette"/>
           <p:cNvSpPr/>
           <p:nvPr/>
         </p:nvSpPr>
         <p:spPr>
           <a:xfrm>
-            <a:off x="548640" y="4160520"/>
-            <a:ext cx="2834640" cy="329184"/>
-          </a:xfrm>
-          <a:prstGeom prst="roundRect">
-            <a:avLst>
-              <a:gd name="adj" fmla="val 50000"/>
-            </a:avLst>
+            <a:off x="5074920" y="1554480"/>
+            <a:ext cx="640080" cy="640080"/>
+          </a:xfrm>
+          <a:prstGeom prst="ellipse">
+            <a:avLst/>
+          </a:prstGeom>
+          <a:solidFill>
+            <a:srgbClr val="E58AA3"/>
+          </a:solidFill>
+          <a:ln w="12700">
+            <a:solidFill>
+              <a:srgbClr val="E58AA3"/>
+            </a:solidFill>
+            <a:prstDash val="solid"/>
+          </a:ln>
+        </p:spPr>
+      </p:sp>
+      <p:pic>
+        <p:nvPicPr>
+          <p:cNvPr id="10" name="icon-orb-FaPalette" descr="orb-FaPalette">    </p:cNvPr>
+          <p:cNvPicPr>
+            <a:picLocks noChangeAspect="1"/>
+          </p:cNvPicPr>
+          <p:nvPr/>
+        </p:nvPicPr>
+        <p:blipFill>
+          <a:blip r:embed="rId2"/>
+          <a:stretch>
+            <a:fillRect/>
+          </a:stretch>
+        </p:blipFill>
+        <p:spPr>
+          <a:xfrm>
+            <a:off x="5247742" y="1727302"/>
+            <a:ext cx="294437" cy="294437"/>
+          </a:xfrm>
+          <a:prstGeom prst="rect">
+            <a:avLst/>
+          </a:prstGeom>
+        </p:spPr>
+      </p:pic>
+      <p:sp>
+        <p:nvSpPr>
+          <p:cNvPr id="11" name="icon-bg-orb-FaUsers"/>
+          <p:cNvSpPr/>
+          <p:nvPr/>
+        </p:nvSpPr>
+        <p:spPr>
+          <a:xfrm>
+            <a:off x="7589520" y="3931920"/>
+            <a:ext cx="640080" cy="640080"/>
+          </a:xfrm>
+          <a:prstGeom prst="ellipse">
+            <a:avLst/>
+          </a:prstGeom>
+          <a:solidFill>
+            <a:srgbClr val="3AA68A"/>
+          </a:solidFill>
+          <a:ln w="12700">
+            <a:solidFill>
+              <a:srgbClr val="3AA68A"/>
+            </a:solidFill>
+            <a:prstDash val="solid"/>
+          </a:ln>
+        </p:spPr>
+      </p:sp>
+      <p:pic>
+        <p:nvPicPr>
+          <p:cNvPr id="12" name="icon-orb-FaUsers" descr="orb-FaUsers">    </p:cNvPr>
+          <p:cNvPicPr>
+            <a:picLocks noChangeAspect="1"/>
+          </p:cNvPicPr>
+          <p:nvPr/>
+        </p:nvPicPr>
+        <p:blipFill>
+          <a:blip r:embed="rId3"/>
+          <a:stretch>
+            <a:fillRect/>
+          </a:stretch>
+        </p:blipFill>
+        <p:spPr>
+          <a:xfrm>
+            <a:off x="7762342" y="4104742"/>
+            <a:ext cx="294437" cy="294437"/>
+          </a:xfrm>
+          <a:prstGeom prst="rect">
+            <a:avLst/>
+          </a:prstGeom>
+        </p:spPr>
+      </p:pic>
+      <p:sp>
+        <p:nvSpPr>
+          <p:cNvPr id="13" name="icon-bg-orb-FaMagic"/>
+          <p:cNvSpPr/>
+          <p:nvPr/>
+        </p:nvSpPr>
+        <p:spPr>
+          <a:xfrm>
+            <a:off x="5394960" y="3840480"/>
+            <a:ext cx="640080" cy="640080"/>
+          </a:xfrm>
+          <a:prstGeom prst="ellipse">
+            <a:avLst/>
+          </a:prstGeom>
+          <a:solidFill>
+            <a:srgbClr val="8B5CF6"/>
+          </a:solidFill>
+          <a:ln w="12700">
+            <a:solidFill>
+              <a:srgbClr val="8B5CF6"/>
+            </a:solidFill>
+            <a:prstDash val="solid"/>
+          </a:ln>
+        </p:spPr>
+      </p:sp>
+      <p:pic>
+        <p:nvPicPr>
+          <p:cNvPr id="14" name="icon-orb-FaMagic" descr="orb-FaMagic">    </p:cNvPr>
+          <p:cNvPicPr>
+            <a:picLocks noChangeAspect="1"/>
+          </p:cNvPicPr>
+          <p:nvPr/>
+        </p:nvPicPr>
+        <p:blipFill>
+          <a:blip r:embed="rId4"/>
+          <a:stretch>
+            <a:fillRect/>
+          </a:stretch>
+        </p:blipFill>
+        <p:spPr>
+          <a:xfrm>
+            <a:off x="5567782" y="4013302"/>
+            <a:ext cx="294437" cy="294437"/>
+          </a:xfrm>
+          <a:prstGeom prst="rect">
+            <a:avLst/>
+          </a:prstGeom>
+        </p:spPr>
+      </p:pic>
+      <p:sp>
+        <p:nvSpPr>
+          <p:cNvPr id="15" name="logo-bg"/>
+          <p:cNvSpPr/>
+          <p:nvPr/>
+        </p:nvSpPr>
+        <p:spPr>
+          <a:xfrm>
+            <a:off x="548640" y="502920"/>
+            <a:ext cx="457200" cy="457200"/>
+          </a:xfrm>
+          <a:prstGeom prst="ellipse">
+            <a:avLst/>
           </a:prstGeom>
           <a:solidFill>
             <a:srgbClr val="E9C978"/>
@@ -3115,7 +3167,246 @@
       </p:sp>
       <p:sp>
         <p:nvSpPr>
-          <p:cNvPr id="11" name="Text 7"/>
+          <p:cNvPr id="16" name="Text 10"/>
+          <p:cNvSpPr txBox="1"/>
+          <p:nvPr/>
+        </p:nvSpPr>
+        <p:spPr>
+          <a:xfrm>
+            <a:off x="548640" y="502920"/>
+            <a:ext cx="457200" cy="457200"/>
+          </a:xfrm>
+          <a:prstGeom prst="rect">
+            <a:avLst/>
+          </a:prstGeom>
+          <a:noFill/>
+          <a:ln/>
+        </p:spPr>
+        <p:txBody>
+          <a:bodyPr wrap="square" lIns="0" tIns="0" rIns="0" bIns="0" rtlCol="0" anchor="ctr"/>
+          <a:lstStyle/>
+          <a:p>
+            <a:pPr algn="ctr" indent="0" marL="0">
+              <a:buNone/>
+            </a:pPr>
+            <a:r>
+              <a:rPr lang="en-US" sz="1800" b="1" dirty="0">
+                <a:solidFill>
+                  <a:srgbClr val="1B1033"/>
+                </a:solidFill>
+                <a:latin typeface="Calibri" pitchFamily="34" charset="0"/>
+                <a:ea typeface="Calibri" pitchFamily="34" charset="-122"/>
+                <a:cs typeface="Calibri" pitchFamily="34" charset="-120"/>
+              </a:rPr>
+              <a:t>✦</a:t>
+            </a:r>
+            <a:endParaRPr lang="en-US" sz="1800" dirty="0"/>
+          </a:p>
+        </p:txBody>
+      </p:sp>
+      <p:sp>
+        <p:nvSpPr>
+          <p:cNvPr id="17" name="Text 11"/>
+          <p:cNvSpPr txBox="1"/>
+          <p:nvPr/>
+        </p:nvSpPr>
+        <p:spPr>
+          <a:xfrm>
+            <a:off x="1097280" y="502920"/>
+            <a:ext cx="2286000" cy="457200"/>
+          </a:xfrm>
+          <a:prstGeom prst="rect">
+            <a:avLst/>
+          </a:prstGeom>
+          <a:noFill/>
+          <a:ln/>
+        </p:spPr>
+        <p:txBody>
+          <a:bodyPr wrap="square" lIns="0" tIns="0" rIns="0" bIns="0" rtlCol="0" anchor="ctr"/>
+          <a:lstStyle/>
+          <a:p>
+            <a:pPr indent="0" marL="0">
+              <a:buNone/>
+            </a:pPr>
+            <a:r>
+              <a:rPr lang="en-US" sz="1300" b="1" spc="600" kern="0" dirty="0">
+                <a:solidFill>
+                  <a:srgbClr val="FFFFFF"/>
+                </a:solidFill>
+                <a:latin typeface="Calibri" pitchFamily="34" charset="0"/>
+                <a:ea typeface="Calibri" pitchFamily="34" charset="-122"/>
+                <a:cs typeface="Calibri" pitchFamily="34" charset="-120"/>
+              </a:rPr>
+              <a:t>WEDVERSE</a:t>
+            </a:r>
+            <a:endParaRPr lang="en-US" sz="1300" dirty="0"/>
+          </a:p>
+        </p:txBody>
+      </p:sp>
+      <p:sp>
+        <p:nvSpPr>
+          <p:cNvPr id="18" name="Text 12"/>
+          <p:cNvSpPr txBox="1"/>
+          <p:nvPr/>
+        </p:nvSpPr>
+        <p:spPr>
+          <a:xfrm>
+            <a:off x="548640" y="1554480"/>
+            <a:ext cx="4572000" cy="274320"/>
+          </a:xfrm>
+          <a:prstGeom prst="rect">
+            <a:avLst/>
+          </a:prstGeom>
+          <a:noFill/>
+          <a:ln/>
+        </p:spPr>
+        <p:txBody>
+          <a:bodyPr wrap="square" lIns="0" tIns="0" rIns="0" bIns="0" rtlCol="0" anchor="ctr"/>
+          <a:lstStyle/>
+          <a:p>
+            <a:pPr indent="0" marL="0">
+              <a:buNone/>
+            </a:pPr>
+            <a:r>
+              <a:rPr lang="en-US" sz="1200" b="1" spc="500" kern="0" dirty="0">
+                <a:solidFill>
+                  <a:srgbClr val="E9C978"/>
+                </a:solidFill>
+                <a:latin typeface="Calibri" pitchFamily="34" charset="0"/>
+                <a:ea typeface="Calibri" pitchFamily="34" charset="-122"/>
+                <a:cs typeface="Calibri" pitchFamily="34" charset="-120"/>
+              </a:rPr>
+              <a:t>PLAN · VISUALIZE · CELEBRATE</a:t>
+            </a:r>
+            <a:endParaRPr lang="en-US" sz="1200" dirty="0"/>
+          </a:p>
+        </p:txBody>
+      </p:sp>
+      <p:sp>
+        <p:nvSpPr>
+          <p:cNvPr id="19" name="Text 13"/>
+          <p:cNvSpPr/>
+          <p:nvPr/>
+        </p:nvSpPr>
+        <p:spPr>
+          <a:xfrm>
+            <a:off x="548640" y="1828800"/>
+            <a:ext cx="5120640" cy="1005840"/>
+          </a:xfrm>
+          <a:prstGeom prst="rect">
+            <a:avLst/>
+          </a:prstGeom>
+          <a:noFill/>
+          <a:ln/>
+        </p:spPr>
+        <p:txBody>
+          <a:bodyPr wrap="square" lIns="0" tIns="0" rIns="0" bIns="0" rtlCol="0" anchor="t"/>
+          <a:lstStyle/>
+          <a:p>
+            <a:pPr indent="0" marL="0">
+              <a:buNone/>
+            </a:pPr>
+            <a:r>
+              <a:rPr lang="en-US" sz="6400" b="1" dirty="0">
+                <a:solidFill>
+                  <a:srgbClr val="FFFFFF"/>
+                </a:solidFill>
+                <a:latin typeface="Cambria" pitchFamily="34" charset="0"/>
+                <a:ea typeface="Cambria" pitchFamily="34" charset="-122"/>
+                <a:cs typeface="Cambria" pitchFamily="34" charset="-120"/>
+              </a:rPr>
+              <a:t>WedVerse AI</a:t>
+            </a:r>
+            <a:endParaRPr lang="en-US" sz="6400" dirty="0"/>
+          </a:p>
+        </p:txBody>
+      </p:sp>
+      <p:sp>
+        <p:nvSpPr>
+          <p:cNvPr id="20" name="Text 14"/>
+          <p:cNvSpPr txBox="1"/>
+          <p:nvPr/>
+        </p:nvSpPr>
+        <p:spPr>
+          <a:xfrm>
+            <a:off x="548640" y="2880360"/>
+            <a:ext cx="4754880" cy="914400"/>
+          </a:xfrm>
+          <a:prstGeom prst="rect">
+            <a:avLst/>
+          </a:prstGeom>
+          <a:noFill/>
+          <a:ln/>
+        </p:spPr>
+        <p:txBody>
+          <a:bodyPr wrap="square" lIns="0" tIns="0" rIns="0" bIns="0" rtlCol="0" anchor="t"/>
+          <a:lstStyle/>
+          <a:p>
+            <a:pPr indent="0" marL="0">
+              <a:buNone/>
+            </a:pPr>
+            <a:r>
+              <a:rPr lang="en-US" sz="2600" i="1" dirty="0">
+                <a:solidFill>
+                  <a:srgbClr val="FFFFFF"/>
+                </a:solidFill>
+                <a:latin typeface="Cambria" pitchFamily="34" charset="0"/>
+                <a:ea typeface="Cambria" pitchFamily="34" charset="-122"/>
+                <a:cs typeface="Cambria" pitchFamily="34" charset="-120"/>
+              </a:rPr>
+              <a:t>See your wedding before</a:t>
+            </a:r>
+            <a:endParaRPr lang="en-US" sz="2600" dirty="0"/>
+          </a:p>
+          <a:p>
+            <a:pPr indent="0" marL="0">
+              <a:buNone/>
+            </a:pPr>
+            <a:r>
+              <a:rPr lang="en-US" sz="2600" i="1" dirty="0">
+                <a:solidFill>
+                  <a:srgbClr val="FFFFFF"/>
+                </a:solidFill>
+                <a:latin typeface="Cambria" pitchFamily="34" charset="0"/>
+                <a:ea typeface="Cambria" pitchFamily="34" charset="-122"/>
+                <a:cs typeface="Cambria" pitchFamily="34" charset="-120"/>
+              </a:rPr>
+              <a:t>you spend on it.</a:t>
+            </a:r>
+            <a:endParaRPr lang="en-US" sz="2600" dirty="0"/>
+          </a:p>
+        </p:txBody>
+      </p:sp>
+      <p:sp>
+        <p:nvSpPr>
+          <p:cNvPr id="21" name="ask-pill"/>
+          <p:cNvSpPr/>
+          <p:nvPr/>
+        </p:nvSpPr>
+        <p:spPr>
+          <a:xfrm>
+            <a:off x="548640" y="4160520"/>
+            <a:ext cx="2834640" cy="329184"/>
+          </a:xfrm>
+          <a:prstGeom prst="roundRect">
+            <a:avLst>
+              <a:gd name="adj" fmla="val 50000"/>
+            </a:avLst>
+          </a:prstGeom>
+          <a:solidFill>
+            <a:srgbClr val="E9C978"/>
+          </a:solidFill>
+          <a:ln w="12700">
+            <a:solidFill>
+              <a:srgbClr val="E9C978"/>
+            </a:solidFill>
+            <a:prstDash val="solid"/>
+          </a:ln>
+        </p:spPr>
+      </p:sp>
+      <p:sp>
+        <p:nvSpPr>
+          <p:cNvPr id="22" name="Text 16"/>
           <p:cNvSpPr txBox="1"/>
           <p:nvPr/>
         </p:nvSpPr>
@@ -4689,57 +4980,81 @@
           <a:chExt cx="0" cy="0"/>
         </a:xfrm>
       </p:grpSpPr>
-      <p:pic>
-        <p:nvPicPr>
-          <p:cNvPr id="2" name="close-3d" descr="3D mandap">    </p:cNvPr>
-          <p:cNvPicPr>
-            <a:picLocks noChangeAspect="1"/>
-          </p:cNvPicPr>
-          <p:nvPr/>
-        </p:nvPicPr>
-        <p:blipFill>
-          <a:blip r:embed="rId1"/>
-          <a:stretch>
-            <a:fillRect/>
-          </a:stretch>
-        </p:blipFill>
-        <p:spPr>
-          <a:xfrm>
-            <a:off x="0" y="0"/>
-            <a:ext cx="9144000" cy="5143500"/>
-          </a:xfrm>
-          <a:prstGeom prst="rect">
-            <a:avLst/>
-          </a:prstGeom>
-        </p:spPr>
-      </p:pic>
-      <p:pic>
-        <p:nvPicPr>
-          <p:cNvPr id="3" name="close-tint" descr="img/ov-tint.png">    </p:cNvPr>
-          <p:cNvPicPr>
-            <a:picLocks noChangeAspect="1"/>
-          </p:cNvPicPr>
-          <p:nvPr/>
-        </p:nvPicPr>
-        <p:blipFill>
-          <a:blip r:embed="rId2"/>
-          <a:stretch>
-            <a:fillRect/>
-          </a:stretch>
-        </p:blipFill>
-        <p:spPr>
-          <a:xfrm>
-            <a:off x="0" y="0"/>
-            <a:ext cx="9144000" cy="5143500"/>
-          </a:xfrm>
-          <a:prstGeom prst="rect">
-            <a:avLst/>
-          </a:prstGeom>
-        </p:spPr>
-      </p:pic>
-      <p:sp>
-        <p:nvSpPr>
-          <p:cNvPr id="4" name="Text 0"/>
+      <p:sp>
+        <p:nvSpPr>
+          <p:cNvPr id="2" name="close-ring-6.2"/>
+          <p:cNvSpPr/>
+          <p:nvPr/>
+        </p:nvSpPr>
+        <p:spPr>
+          <a:xfrm>
+            <a:off x="1737360" y="-320040"/>
+            <a:ext cx="5669280" cy="5669280"/>
+          </a:xfrm>
+          <a:prstGeom prst="ellipse">
+            <a:avLst/>
+          </a:prstGeom>
+          <a:ln w="12700">
+            <a:solidFill>
+              <a:srgbClr val="E9C978">
+                <a:alpha val="15000"/>
+              </a:srgbClr>
+            </a:solidFill>
+            <a:prstDash val="solid"/>
+          </a:ln>
+        </p:spPr>
+      </p:sp>
+      <p:sp>
+        <p:nvSpPr>
+          <p:cNvPr id="3" name="close-ring-4.6"/>
+          <p:cNvSpPr/>
+          <p:nvPr/>
+        </p:nvSpPr>
+        <p:spPr>
+          <a:xfrm>
+            <a:off x="2468880" y="411480"/>
+            <a:ext cx="4206240" cy="4206240"/>
+          </a:xfrm>
+          <a:prstGeom prst="ellipse">
+            <a:avLst/>
+          </a:prstGeom>
+          <a:ln w="12700">
+            <a:solidFill>
+              <a:srgbClr val="E9C978">
+                <a:alpha val="22000"/>
+              </a:srgbClr>
+            </a:solidFill>
+            <a:prstDash val="solid"/>
+          </a:ln>
+        </p:spPr>
+      </p:sp>
+      <p:sp>
+        <p:nvSpPr>
+          <p:cNvPr id="4" name="close-ring-3.2"/>
+          <p:cNvSpPr/>
+          <p:nvPr/>
+        </p:nvSpPr>
+        <p:spPr>
+          <a:xfrm>
+            <a:off x="3108960" y="1051560"/>
+            <a:ext cx="2926080" cy="2926080"/>
+          </a:xfrm>
+          <a:prstGeom prst="ellipse">
+            <a:avLst/>
+          </a:prstGeom>
+          <a:ln w="12700">
+            <a:solidFill>
+              <a:srgbClr val="E9C978">
+                <a:alpha val="32000"/>
+              </a:srgbClr>
+            </a:solidFill>
+            <a:prstDash val="solid"/>
+          </a:ln>
+        </p:spPr>
+      </p:sp>
+      <p:sp>
+        <p:nvSpPr>
+          <p:cNvPr id="5" name="Text 3"/>
           <p:cNvSpPr/>
           <p:nvPr/>
         </p:nvSpPr>
@@ -4795,7 +5110,7 @@
       </p:sp>
       <p:sp>
         <p:nvSpPr>
-          <p:cNvPr id="5" name="Text 1"/>
+          <p:cNvPr id="6" name="Text 4"/>
           <p:cNvSpPr txBox="1"/>
           <p:nvPr/>
         </p:nvSpPr>
@@ -4834,7 +5149,7 @@
       </p:sp>
       <p:sp>
         <p:nvSpPr>
-          <p:cNvPr id="6" name="close-pill"/>
+          <p:cNvPr id="7" name="close-pill"/>
           <p:cNvSpPr/>
           <p:nvPr/>
         </p:nvSpPr>
@@ -4861,7 +5176,7 @@
       </p:sp>
       <p:sp>
         <p:nvSpPr>
-          <p:cNvPr id="7" name="Text 3"/>
+          <p:cNvPr id="8" name="Text 6"/>
           <p:cNvSpPr txBox="1"/>
           <p:nvPr/>
         </p:nvSpPr>
@@ -6349,13 +6664,36 @@
       </p:sp>
       <p:sp>
         <p:nvSpPr>
-          <p:cNvPr id="3" name="icon-bg-step-0"/>
+          <p:cNvPr id="3" name="flow-line"/>
           <p:cNvSpPr/>
           <p:nvPr/>
         </p:nvSpPr>
         <p:spPr>
           <a:xfrm>
-            <a:off x="548640" y="1280160"/>
+            <a:off x="1371600" y="1783080"/>
+            <a:ext cx="6400800" cy="0"/>
+          </a:xfrm>
+          <a:prstGeom prst="line">
+            <a:avLst/>
+          </a:prstGeom>
+          <a:noFill/>
+          <a:ln w="25400">
+            <a:solidFill>
+              <a:srgbClr val="C9BFEA"/>
+            </a:solidFill>
+            <a:prstDash val="dash"/>
+          </a:ln>
+        </p:spPr>
+      </p:sp>
+      <p:sp>
+        <p:nvSpPr>
+          <p:cNvPr id="4" name="icon-bg-step-0"/>
+          <p:cNvSpPr/>
+          <p:nvPr/>
+        </p:nvSpPr>
+        <p:spPr>
+          <a:xfrm>
+            <a:off x="1463040" y="1417320"/>
             <a:ext cx="731520" cy="731520"/>
           </a:xfrm>
           <a:prstGeom prst="ellipse">
@@ -6374,7 +6712,7 @@
       </p:sp>
       <p:pic>
         <p:nvPicPr>
-          <p:cNvPr id="4" name="icon-step-0" descr="step-0">    </p:cNvPr>
+          <p:cNvPr id="5" name="icon-step-0" descr="step-0">    </p:cNvPr>
           <p:cNvPicPr>
             <a:picLocks noChangeAspect="1"/>
           </p:cNvPicPr>
@@ -6388,7 +6726,7 @@
         </p:blipFill>
         <p:spPr>
           <a:xfrm>
-            <a:off x="746150" y="1477670"/>
+            <a:off x="1660550" y="1614830"/>
             <a:ext cx="336499" cy="336499"/>
           </a:xfrm>
           <a:prstGeom prst="rect">
@@ -6398,14 +6736,48 @@
       </p:pic>
       <p:sp>
         <p:nvSpPr>
-          <p:cNvPr id="5" name="Text 2"/>
+          <p:cNvPr id="6" name="step-card-0"/>
+          <p:cNvSpPr/>
+          <p:nvPr/>
+        </p:nvSpPr>
+        <p:spPr>
+          <a:xfrm>
+            <a:off x="548640" y="2423160"/>
+            <a:ext cx="2560320" cy="1600200"/>
+          </a:xfrm>
+          <a:prstGeom prst="roundRect">
+            <a:avLst>
+              <a:gd name="adj" fmla="val 8000"/>
+            </a:avLst>
+          </a:prstGeom>
+          <a:solidFill>
+            <a:srgbClr val="FFFFFF"/>
+          </a:solidFill>
+          <a:ln w="9525">
+            <a:solidFill>
+              <a:srgbClr val="E6DEFA"/>
+            </a:solidFill>
+            <a:prstDash val="solid"/>
+          </a:ln>
+          <a:effectLst>
+            <a:outerShdw sx="100000" sy="100000" kx="0" ky="0" algn="bl" rotWithShape="0" blurRad="101600" dist="25400" dir="5400000">
+              <a:srgbClr val="1B1033">
+                <a:alpha val="12000"/>
+              </a:srgbClr>
+            </a:outerShdw>
+          </a:effectLst>
+        </p:spPr>
+      </p:sp>
+      <p:sp>
+        <p:nvSpPr>
+          <p:cNvPr id="7" name="Text 4"/>
           <p:cNvSpPr txBox="1"/>
           <p:nvPr/>
         </p:nvSpPr>
         <p:spPr>
           <a:xfrm>
-            <a:off x="1463040" y="1298448"/>
-            <a:ext cx="3108960" cy="365760"/>
+            <a:off x="731520" y="2560320"/>
+            <a:ext cx="2194560" cy="365760"/>
           </a:xfrm>
           <a:prstGeom prst="rect">
             <a:avLst/>
@@ -6421,7 +6793,7 @@
               <a:buNone/>
             </a:pPr>
             <a:r>
-              <a:rPr lang="en-US" sz="2000" b="1" dirty="0">
+              <a:rPr lang="en-US" sz="1900" b="1" dirty="0">
                 <a:solidFill>
                   <a:srgbClr val="1B1033"/>
                 </a:solidFill>
@@ -6429,22 +6801,22 @@
                 <a:ea typeface="Cambria" pitchFamily="34" charset="-122"/>
                 <a:cs typeface="Cambria" pitchFamily="34" charset="-120"/>
               </a:rPr>
-              <a:t>Upload your venue</a:t>
+              <a:t>1  Upload venue</a:t>
             </a:r>
-            <a:endParaRPr lang="en-US" sz="2000" dirty="0"/>
-          </a:p>
-        </p:txBody>
-      </p:sp>
-      <p:sp>
-        <p:nvSpPr>
-          <p:cNvPr id="6" name="Text 3"/>
+            <a:endParaRPr lang="en-US" sz="1900" dirty="0"/>
+          </a:p>
+        </p:txBody>
+      </p:sp>
+      <p:sp>
+        <p:nvSpPr>
+          <p:cNvPr id="8" name="Text 5"/>
           <p:cNvSpPr txBox="1"/>
           <p:nvPr/>
         </p:nvSpPr>
         <p:spPr>
           <a:xfrm>
-            <a:off x="1463040" y="1691640"/>
-            <a:ext cx="3108960" cy="640080"/>
+            <a:off x="731520" y="2999232"/>
+            <a:ext cx="2194560" cy="914400"/>
           </a:xfrm>
           <a:prstGeom prst="rect">
             <a:avLst/>
@@ -6468,7 +6840,7 @@
                 <a:ea typeface="Calibri" pitchFamily="34" charset="-122"/>
                 <a:cs typeface="Calibri" pitchFamily="34" charset="-120"/>
               </a:rPr>
-              <a:t>Photos, floor plan or video become a 3D digital twin.</a:t>
+              <a:t>Photos, floor plan or video become a digital twin of your hall.</a:t>
             </a:r>
             <a:endParaRPr lang="en-US" sz="1400" dirty="0"/>
           </a:p>
@@ -6476,13 +6848,13 @@
       </p:sp>
       <p:sp>
         <p:nvSpPr>
-          <p:cNvPr id="7" name="icon-bg-step-1"/>
+          <p:cNvPr id="9" name="icon-bg-step-1"/>
           <p:cNvSpPr/>
           <p:nvPr/>
         </p:nvSpPr>
         <p:spPr>
           <a:xfrm>
-            <a:off x="548640" y="2377440"/>
+            <a:off x="4206240" y="1417320"/>
             <a:ext cx="731520" cy="731520"/>
           </a:xfrm>
           <a:prstGeom prst="ellipse">
@@ -6501,7 +6873,7 @@
       </p:sp>
       <p:pic>
         <p:nvPicPr>
-          <p:cNvPr id="8" name="icon-step-1" descr="step-1">    </p:cNvPr>
+          <p:cNvPr id="10" name="icon-step-1" descr="step-1">    </p:cNvPr>
           <p:cNvPicPr>
             <a:picLocks noChangeAspect="1"/>
           </p:cNvPicPr>
@@ -6515,7 +6887,7 @@
         </p:blipFill>
         <p:spPr>
           <a:xfrm>
-            <a:off x="746150" y="2574950"/>
+            <a:off x="4403750" y="1614830"/>
             <a:ext cx="336499" cy="336499"/>
           </a:xfrm>
           <a:prstGeom prst="rect">
@@ -6525,14 +6897,48 @@
       </p:pic>
       <p:sp>
         <p:nvSpPr>
-          <p:cNvPr id="9" name="Text 5"/>
+          <p:cNvPr id="11" name="step-card-1"/>
+          <p:cNvSpPr/>
+          <p:nvPr/>
+        </p:nvSpPr>
+        <p:spPr>
+          <a:xfrm>
+            <a:off x="3291840" y="2423160"/>
+            <a:ext cx="2560320" cy="1600200"/>
+          </a:xfrm>
+          <a:prstGeom prst="roundRect">
+            <a:avLst>
+              <a:gd name="adj" fmla="val 8000"/>
+            </a:avLst>
+          </a:prstGeom>
+          <a:solidFill>
+            <a:srgbClr val="FFFFFF"/>
+          </a:solidFill>
+          <a:ln w="9525">
+            <a:solidFill>
+              <a:srgbClr val="E6DEFA"/>
+            </a:solidFill>
+            <a:prstDash val="solid"/>
+          </a:ln>
+          <a:effectLst>
+            <a:outerShdw sx="100000" sy="100000" kx="0" ky="0" algn="bl" rotWithShape="0" blurRad="101600" dist="25400" dir="5400000">
+              <a:srgbClr val="1B1033">
+                <a:alpha val="12000"/>
+              </a:srgbClr>
+            </a:outerShdw>
+          </a:effectLst>
+        </p:spPr>
+      </p:sp>
+      <p:sp>
+        <p:nvSpPr>
+          <p:cNvPr id="12" name="Text 8"/>
           <p:cNvSpPr txBox="1"/>
           <p:nvPr/>
         </p:nvSpPr>
         <p:spPr>
           <a:xfrm>
-            <a:off x="1463040" y="2395728"/>
-            <a:ext cx="3108960" cy="365760"/>
+            <a:off x="3474720" y="2560320"/>
+            <a:ext cx="2194560" cy="365760"/>
           </a:xfrm>
           <a:prstGeom prst="rect">
             <a:avLst/>
@@ -6548,7 +6954,7 @@
               <a:buNone/>
             </a:pPr>
             <a:r>
-              <a:rPr lang="en-US" sz="2000" b="1" dirty="0">
+              <a:rPr lang="en-US" sz="1900" b="1" dirty="0">
                 <a:solidFill>
                   <a:srgbClr val="1B1033"/>
                 </a:solidFill>
@@ -6556,22 +6962,22 @@
                 <a:ea typeface="Cambria" pitchFamily="34" charset="-122"/>
                 <a:cs typeface="Cambria" pitchFamily="34" charset="-120"/>
               </a:rPr>
-              <a:t>Design it in 3D</a:t>
+              <a:t>2  Design the day</a:t>
             </a:r>
-            <a:endParaRPr lang="en-US" sz="2000" dirty="0"/>
-          </a:p>
-        </p:txBody>
-      </p:sp>
-      <p:sp>
-        <p:nvSpPr>
-          <p:cNvPr id="10" name="Text 6"/>
+            <a:endParaRPr lang="en-US" sz="1900" dirty="0"/>
+          </a:p>
+        </p:txBody>
+      </p:sp>
+      <p:sp>
+        <p:nvSpPr>
+          <p:cNvPr id="13" name="Text 9"/>
           <p:cNvSpPr txBox="1"/>
           <p:nvPr/>
         </p:nvSpPr>
         <p:spPr>
           <a:xfrm>
-            <a:off x="1463040" y="2788920"/>
-            <a:ext cx="3108960" cy="640080"/>
+            <a:off x="3474720" y="2999232"/>
+            <a:ext cx="2194560" cy="914400"/>
           </a:xfrm>
           <a:prstGeom prst="rect">
             <a:avLst/>
@@ -6603,13 +7009,13 @@
       </p:sp>
       <p:sp>
         <p:nvSpPr>
-          <p:cNvPr id="11" name="icon-bg-step-2"/>
+          <p:cNvPr id="14" name="icon-bg-step-2"/>
           <p:cNvSpPr/>
           <p:nvPr/>
         </p:nvSpPr>
         <p:spPr>
           <a:xfrm>
-            <a:off x="548640" y="3474720"/>
+            <a:off x="6949440" y="1417320"/>
             <a:ext cx="731520" cy="731520"/>
           </a:xfrm>
           <a:prstGeom prst="ellipse">
@@ -6628,7 +7034,7 @@
       </p:sp>
       <p:pic>
         <p:nvPicPr>
-          <p:cNvPr id="12" name="icon-step-2" descr="step-2">    </p:cNvPr>
+          <p:cNvPr id="15" name="icon-step-2" descr="step-2">    </p:cNvPr>
           <p:cNvPicPr>
             <a:picLocks noChangeAspect="1"/>
           </p:cNvPicPr>
@@ -6642,7 +7048,7 @@
         </p:blipFill>
         <p:spPr>
           <a:xfrm>
-            <a:off x="746150" y="3672230"/>
+            <a:off x="7146950" y="1614830"/>
             <a:ext cx="336499" cy="336499"/>
           </a:xfrm>
           <a:prstGeom prst="rect">
@@ -6652,14 +7058,48 @@
       </p:pic>
       <p:sp>
         <p:nvSpPr>
-          <p:cNvPr id="13" name="Text 8"/>
+          <p:cNvPr id="16" name="step-card-2"/>
+          <p:cNvSpPr/>
+          <p:nvPr/>
+        </p:nvSpPr>
+        <p:spPr>
+          <a:xfrm>
+            <a:off x="6035040" y="2423160"/>
+            <a:ext cx="2560320" cy="1600200"/>
+          </a:xfrm>
+          <a:prstGeom prst="roundRect">
+            <a:avLst>
+              <a:gd name="adj" fmla="val 8000"/>
+            </a:avLst>
+          </a:prstGeom>
+          <a:solidFill>
+            <a:srgbClr val="FFFFFF"/>
+          </a:solidFill>
+          <a:ln w="9525">
+            <a:solidFill>
+              <a:srgbClr val="E6DEFA"/>
+            </a:solidFill>
+            <a:prstDash val="solid"/>
+          </a:ln>
+          <a:effectLst>
+            <a:outerShdw sx="100000" sy="100000" kx="0" ky="0" algn="bl" rotWithShape="0" blurRad="101600" dist="25400" dir="5400000">
+              <a:srgbClr val="1B1033">
+                <a:alpha val="12000"/>
+              </a:srgbClr>
+            </a:outerShdw>
+          </a:effectLst>
+        </p:spPr>
+      </p:sp>
+      <p:sp>
+        <p:nvSpPr>
+          <p:cNvPr id="17" name="Text 12"/>
           <p:cNvSpPr txBox="1"/>
           <p:nvPr/>
         </p:nvSpPr>
         <p:spPr>
           <a:xfrm>
-            <a:off x="1463040" y="3493008"/>
-            <a:ext cx="3108960" cy="365760"/>
+            <a:off x="6217920" y="2560320"/>
+            <a:ext cx="2194560" cy="365760"/>
           </a:xfrm>
           <a:prstGeom prst="rect">
             <a:avLst/>
@@ -6675,7 +7115,7 @@
               <a:buNone/>
             </a:pPr>
             <a:r>
-              <a:rPr lang="en-US" sz="2000" b="1" dirty="0">
+              <a:rPr lang="en-US" sz="1900" b="1" dirty="0">
                 <a:solidFill>
                   <a:srgbClr val="1B1033"/>
                 </a:solidFill>
@@ -6683,22 +7123,22 @@
                 <a:ea typeface="Cambria" pitchFamily="34" charset="-122"/>
                 <a:cs typeface="Cambria" pitchFamily="34" charset="-120"/>
               </a:rPr>
-              <a:t>Optimise the budget</a:t>
+              <a:t>3  Optimise budget</a:t>
             </a:r>
-            <a:endParaRPr lang="en-US" sz="2000" dirty="0"/>
-          </a:p>
-        </p:txBody>
-      </p:sp>
-      <p:sp>
-        <p:nvSpPr>
-          <p:cNvPr id="14" name="Text 9"/>
+            <a:endParaRPr lang="en-US" sz="1900" dirty="0"/>
+          </a:p>
+        </p:txBody>
+      </p:sp>
+      <p:sp>
+        <p:nvSpPr>
+          <p:cNvPr id="18" name="Text 13"/>
           <p:cNvSpPr txBox="1"/>
           <p:nvPr/>
         </p:nvSpPr>
         <p:spPr>
           <a:xfrm>
-            <a:off x="1463040" y="3886200"/>
-            <a:ext cx="3108960" cy="640080"/>
+            <a:off x="6217920" y="2999232"/>
+            <a:ext cx="2194560" cy="914400"/>
           </a:xfrm>
           <a:prstGeom prst="rect">
             <a:avLst/>
@@ -6728,53 +7168,71 @@
           </a:p>
         </p:txBody>
       </p:sp>
-      <p:pic>
-        <p:nvPicPr>
-          <p:cNvPr id="15" name="solution-shot" descr="3D venue preview">    </p:cNvPr>
-          <p:cNvPicPr>
-            <a:picLocks noChangeAspect="1"/>
-          </p:cNvPicPr>
-          <p:nvPr/>
-        </p:nvPicPr>
-        <p:blipFill>
-          <a:blip r:embed="rId4"/>
-          <a:stretch>
-            <a:fillRect/>
-          </a:stretch>
-        </p:blipFill>
-        <p:spPr>
-          <a:xfrm>
-            <a:off x="4983480" y="1097280"/>
-            <a:ext cx="3611880" cy="3611880"/>
-          </a:xfrm>
-          <a:prstGeom prst="rect">
-            <a:avLst/>
-          </a:prstGeom>
-        </p:spPr>
-      </p:pic>
-      <p:sp>
-        <p:nvSpPr>
-          <p:cNvPr id="16" name="solution-frame"/>
+      <p:sp>
+        <p:nvSpPr>
+          <p:cNvPr id="19" name="tagline"/>
           <p:cNvSpPr/>
           <p:nvPr/>
         </p:nvSpPr>
         <p:spPr>
           <a:xfrm>
-            <a:off x="4928616" y="1042416"/>
-            <a:ext cx="3721608" cy="3721608"/>
+            <a:off x="548640" y="4206240"/>
+            <a:ext cx="8046720" cy="502920"/>
           </a:xfrm>
           <a:prstGeom prst="roundRect">
             <a:avLst>
-              <a:gd name="adj" fmla="val 4914"/>
+              <a:gd name="adj" fmla="val 25455"/>
             </a:avLst>
           </a:prstGeom>
-          <a:ln w="15875">
+          <a:solidFill>
+            <a:srgbClr val="1B1033"/>
+          </a:solidFill>
+          <a:ln w="12700">
             <a:solidFill>
-              <a:srgbClr val="E9C978"/>
+              <a:srgbClr val="1B1033"/>
             </a:solidFill>
             <a:prstDash val="solid"/>
           </a:ln>
         </p:spPr>
+      </p:sp>
+      <p:sp>
+        <p:nvSpPr>
+          <p:cNvPr id="20" name="Text 15"/>
+          <p:cNvSpPr txBox="1"/>
+          <p:nvPr/>
+        </p:nvSpPr>
+        <p:spPr>
+          <a:xfrm>
+            <a:off x="731520" y="4206240"/>
+            <a:ext cx="7680960" cy="502920"/>
+          </a:xfrm>
+          <a:prstGeom prst="rect">
+            <a:avLst/>
+          </a:prstGeom>
+          <a:noFill/>
+          <a:ln/>
+        </p:spPr>
+        <p:txBody>
+          <a:bodyPr wrap="square" lIns="0" tIns="0" rIns="0" bIns="0" rtlCol="0" anchor="ctr"/>
+          <a:lstStyle/>
+          <a:p>
+            <a:pPr indent="0" marL="0">
+              <a:buNone/>
+            </a:pPr>
+            <a:r>
+              <a:rPr lang="en-US" sz="1400" i="1" dirty="0">
+                <a:solidFill>
+                  <a:srgbClr val="FFFFFF"/>
+                </a:solidFill>
+                <a:latin typeface="Calibri" pitchFamily="34" charset="0"/>
+                <a:ea typeface="Calibri" pitchFamily="34" charset="-122"/>
+                <a:cs typeface="Calibri" pitchFamily="34" charset="-120"/>
+              </a:rPr>
+              <a:t>Couples preview, customise and optimise their wedding before booking a single vendor.</a:t>
+            </a:r>
+            <a:endParaRPr lang="en-US" sz="1400" dirty="0"/>
+          </a:p>
+        </p:txBody>
       </p:sp>
       <p:sp>
         <p:nvSpPr>
@@ -6879,15 +7337,71 @@
                 <a:ea typeface="Cambria" pitchFamily="34" charset="-122"/>
                 <a:cs typeface="Cambria" pitchFamily="34" charset="-120"/>
               </a:rPr>
-              <a:t>Live product — not a mock-up</a:t>
+              <a:t>What the product does</a:t>
             </a:r>
             <a:endParaRPr lang="en-US" sz="3200" dirty="0"/>
           </a:p>
         </p:txBody>
       </p:sp>
+      <p:sp>
+        <p:nvSpPr>
+          <p:cNvPr id="3" name="feat-0"/>
+          <p:cNvSpPr/>
+          <p:nvPr/>
+        </p:nvSpPr>
+        <p:spPr>
+          <a:xfrm>
+            <a:off x="548640" y="1280160"/>
+            <a:ext cx="2560320" cy="1463040"/>
+          </a:xfrm>
+          <a:prstGeom prst="roundRect">
+            <a:avLst>
+              <a:gd name="adj" fmla="val 8750"/>
+            </a:avLst>
+          </a:prstGeom>
+          <a:solidFill>
+            <a:srgbClr val="FFFFFF">
+              <a:alpha val="10000"/>
+            </a:srgbClr>
+          </a:solidFill>
+          <a:ln w="9525">
+            <a:solidFill>
+              <a:srgbClr val="E9C978">
+                <a:alpha val="55000"/>
+              </a:srgbClr>
+            </a:solidFill>
+            <a:prstDash val="solid"/>
+          </a:ln>
+        </p:spPr>
+      </p:sp>
+      <p:sp>
+        <p:nvSpPr>
+          <p:cNvPr id="4" name="icon-bg-feat-0"/>
+          <p:cNvSpPr/>
+          <p:nvPr/>
+        </p:nvSpPr>
+        <p:spPr>
+          <a:xfrm>
+            <a:off x="731520" y="1463040"/>
+            <a:ext cx="502920" cy="502920"/>
+          </a:xfrm>
+          <a:prstGeom prst="ellipse">
+            <a:avLst/>
+          </a:prstGeom>
+          <a:solidFill>
+            <a:srgbClr val="5B52E0"/>
+          </a:solidFill>
+          <a:ln w="12700">
+            <a:solidFill>
+              <a:srgbClr val="5B52E0"/>
+            </a:solidFill>
+            <a:prstDash val="solid"/>
+          </a:ln>
+        </p:spPr>
+      </p:sp>
       <p:pic>
         <p:nvPicPr>
-          <p:cNvPr id="3" name="app-stage" descr="3D venue preview in the WedVerse studio">    </p:cNvPr>
+          <p:cNvPr id="5" name="icon-feat-0" descr="feat-0">    </p:cNvPr>
           <p:cNvPicPr>
             <a:picLocks noChangeAspect="1"/>
           </p:cNvPicPr>
@@ -6901,8 +7415,8 @@
         </p:blipFill>
         <p:spPr>
           <a:xfrm>
-            <a:off x="548640" y="1188720"/>
-            <a:ext cx="4663440" cy="2957159"/>
+            <a:off x="867308" y="1598828"/>
+            <a:ext cx="231343" cy="231343"/>
           </a:xfrm>
           <a:prstGeom prst="rect">
             <a:avLst/>
@@ -6911,31 +7425,141 @@
       </p:pic>
       <p:sp>
         <p:nvSpPr>
-          <p:cNvPr id="4" name="app-stage-frame"/>
+          <p:cNvPr id="6" name="Text 3"/>
+          <p:cNvSpPr txBox="1"/>
+          <p:nvPr/>
+        </p:nvSpPr>
+        <p:spPr>
+          <a:xfrm>
+            <a:off x="1371600" y="1463040"/>
+            <a:ext cx="1645920" cy="502920"/>
+          </a:xfrm>
+          <a:prstGeom prst="rect">
+            <a:avLst/>
+          </a:prstGeom>
+          <a:noFill/>
+          <a:ln/>
+        </p:spPr>
+        <p:txBody>
+          <a:bodyPr wrap="square" lIns="0" tIns="0" rIns="0" bIns="0" rtlCol="0" anchor="ctr"/>
+          <a:lstStyle/>
+          <a:p>
+            <a:pPr indent="0" marL="0">
+              <a:buNone/>
+            </a:pPr>
+            <a:r>
+              <a:rPr lang="en-US" sz="1600" b="1" dirty="0">
+                <a:solidFill>
+                  <a:srgbClr val="FFFFFF"/>
+                </a:solidFill>
+                <a:latin typeface="Cambria" pitchFamily="34" charset="0"/>
+                <a:ea typeface="Cambria" pitchFamily="34" charset="-122"/>
+                <a:cs typeface="Cambria" pitchFamily="34" charset="-120"/>
+              </a:rPr>
+              <a:t>Digital twin</a:t>
+            </a:r>
+            <a:endParaRPr lang="en-US" sz="1600" dirty="0"/>
+          </a:p>
+        </p:txBody>
+      </p:sp>
+      <p:sp>
+        <p:nvSpPr>
+          <p:cNvPr id="7" name="Text 4"/>
+          <p:cNvSpPr txBox="1"/>
+          <p:nvPr/>
+        </p:nvSpPr>
+        <p:spPr>
+          <a:xfrm>
+            <a:off x="731520" y="2103120"/>
+            <a:ext cx="2194560" cy="548640"/>
+          </a:xfrm>
+          <a:prstGeom prst="rect">
+            <a:avLst/>
+          </a:prstGeom>
+          <a:noFill/>
+          <a:ln/>
+        </p:spPr>
+        <p:txBody>
+          <a:bodyPr wrap="square" lIns="0" tIns="0" rIns="0" bIns="0" rtlCol="0" anchor="t"/>
+          <a:lstStyle/>
+          <a:p>
+            <a:pPr indent="0" marL="0">
+              <a:buNone/>
+            </a:pPr>
+            <a:r>
+              <a:rPr lang="en-US" sz="1400" dirty="0">
+                <a:solidFill>
+                  <a:srgbClr val="FFFFFF"/>
+                </a:solidFill>
+                <a:latin typeface="Calibri" pitchFamily="34" charset="0"/>
+                <a:ea typeface="Calibri" pitchFamily="34" charset="-122"/>
+                <a:cs typeface="Calibri" pitchFamily="34" charset="-120"/>
+              </a:rPr>
+              <a:t>Upload photos, plans or video of any hall.</a:t>
+            </a:r>
+            <a:endParaRPr lang="en-US" sz="1400" dirty="0"/>
+          </a:p>
+        </p:txBody>
+      </p:sp>
+      <p:sp>
+        <p:nvSpPr>
+          <p:cNvPr id="8" name="feat-1"/>
           <p:cNvSpPr/>
           <p:nvPr/>
         </p:nvSpPr>
         <p:spPr>
           <a:xfrm>
-            <a:off x="493776" y="1133856"/>
-            <a:ext cx="4773168" cy="3066887"/>
+            <a:off x="3291840" y="1280160"/>
+            <a:ext cx="2560320" cy="1463040"/>
           </a:xfrm>
           <a:prstGeom prst="roundRect">
             <a:avLst>
-              <a:gd name="adj" fmla="val 5963"/>
+              <a:gd name="adj" fmla="val 8750"/>
             </a:avLst>
           </a:prstGeom>
-          <a:ln w="15875">
+          <a:solidFill>
+            <a:srgbClr val="FFFFFF">
+              <a:alpha val="10000"/>
+            </a:srgbClr>
+          </a:solidFill>
+          <a:ln w="9525">
             <a:solidFill>
-              <a:srgbClr val="E9C978"/>
+              <a:srgbClr val="E9C978">
+                <a:alpha val="55000"/>
+              </a:srgbClr>
             </a:solidFill>
             <a:prstDash val="solid"/>
           </a:ln>
         </p:spPr>
       </p:sp>
+      <p:sp>
+        <p:nvSpPr>
+          <p:cNvPr id="9" name="icon-bg-feat-1"/>
+          <p:cNvSpPr/>
+          <p:nvPr/>
+        </p:nvSpPr>
+        <p:spPr>
+          <a:xfrm>
+            <a:off x="3474720" y="1463040"/>
+            <a:ext cx="502920" cy="502920"/>
+          </a:xfrm>
+          <a:prstGeom prst="ellipse">
+            <a:avLst/>
+          </a:prstGeom>
+          <a:solidFill>
+            <a:srgbClr val="E58AA3"/>
+          </a:solidFill>
+          <a:ln w="12700">
+            <a:solidFill>
+              <a:srgbClr val="E58AA3"/>
+            </a:solidFill>
+            <a:prstDash val="solid"/>
+          </a:ln>
+        </p:spPr>
+      </p:sp>
       <p:pic>
         <p:nvPicPr>
-          <p:cNvPr id="5" name="app-budget" descr="Budget optimizer panel">    </p:cNvPr>
+          <p:cNvPr id="10" name="icon-feat-1" descr="feat-1">    </p:cNvPr>
           <p:cNvPicPr>
             <a:picLocks noChangeAspect="1"/>
           </p:cNvPicPr>
@@ -6949,8 +7573,8 @@
         </p:blipFill>
         <p:spPr>
           <a:xfrm>
-            <a:off x="5577840" y="1188720"/>
-            <a:ext cx="2926080" cy="3149144"/>
+            <a:off x="3610508" y="1598828"/>
+            <a:ext cx="231343" cy="231343"/>
           </a:xfrm>
           <a:prstGeom prst="rect">
             <a:avLst/>
@@ -6959,38 +7583,14 @@
       </p:pic>
       <p:sp>
         <p:nvSpPr>
-          <p:cNvPr id="6" name="app-budget-frame"/>
-          <p:cNvSpPr/>
-          <p:nvPr/>
-        </p:nvSpPr>
-        <p:spPr>
-          <a:xfrm>
-            <a:off x="5522976" y="1133856"/>
-            <a:ext cx="3035808" cy="3258872"/>
-          </a:xfrm>
-          <a:prstGeom prst="roundRect">
-            <a:avLst>
-              <a:gd name="adj" fmla="val 6024"/>
-            </a:avLst>
-          </a:prstGeom>
-          <a:ln w="15875">
-            <a:solidFill>
-              <a:srgbClr val="E9C978"/>
-            </a:solidFill>
-            <a:prstDash val="solid"/>
-          </a:ln>
-        </p:spPr>
-      </p:sp>
-      <p:sp>
-        <p:nvSpPr>
-          <p:cNvPr id="7" name="Text 3"/>
+          <p:cNvPr id="11" name="Text 7"/>
           <p:cNvSpPr txBox="1"/>
           <p:nvPr/>
         </p:nvSpPr>
         <p:spPr>
           <a:xfrm>
-            <a:off x="548640" y="4480560"/>
-            <a:ext cx="4663440" cy="274320"/>
+            <a:off x="4114800" y="1463040"/>
+            <a:ext cx="1645920" cy="502920"/>
           </a:xfrm>
           <a:prstGeom prst="rect">
             <a:avLst/>
@@ -7006,15 +7606,54 @@
               <a:buNone/>
             </a:pPr>
             <a:r>
-              <a:rPr lang="en-US" sz="1400" b="1" dirty="0">
-                <a:solidFill>
-                  <a:srgbClr val="E9C978"/>
+              <a:rPr lang="en-US" sz="1600" b="1" dirty="0">
+                <a:solidFill>
+                  <a:srgbClr val="FFFFFF"/>
+                </a:solidFill>
+                <a:latin typeface="Cambria" pitchFamily="34" charset="0"/>
+                <a:ea typeface="Cambria" pitchFamily="34" charset="-122"/>
+                <a:cs typeface="Cambria" pitchFamily="34" charset="-120"/>
+              </a:rPr>
+              <a:t>Themes &amp; layouts</a:t>
+            </a:r>
+            <a:endParaRPr lang="en-US" sz="1600" dirty="0"/>
+          </a:p>
+        </p:txBody>
+      </p:sp>
+      <p:sp>
+        <p:nvSpPr>
+          <p:cNvPr id="12" name="Text 8"/>
+          <p:cNvSpPr txBox="1"/>
+          <p:nvPr/>
+        </p:nvSpPr>
+        <p:spPr>
+          <a:xfrm>
+            <a:off x="3474720" y="2103120"/>
+            <a:ext cx="2194560" cy="548640"/>
+          </a:xfrm>
+          <a:prstGeom prst="rect">
+            <a:avLst/>
+          </a:prstGeom>
+          <a:noFill/>
+          <a:ln/>
+        </p:spPr>
+        <p:txBody>
+          <a:bodyPr wrap="square" lIns="0" tIns="0" rIns="0" bIns="0" rtlCol="0" anchor="t"/>
+          <a:lstStyle/>
+          <a:p>
+            <a:pPr indent="0" marL="0">
+              <a:buNone/>
+            </a:pPr>
+            <a:r>
+              <a:rPr lang="en-US" sz="1400" dirty="0">
+                <a:solidFill>
+                  <a:srgbClr val="FFFFFF"/>
                 </a:solidFill>
                 <a:latin typeface="Calibri" pitchFamily="34" charset="0"/>
                 <a:ea typeface="Calibri" pitchFamily="34" charset="-122"/>
                 <a:cs typeface="Calibri" pitchFamily="34" charset="-120"/>
               </a:rPr>
-              <a:t>Live 3D preview — drag, zoom, walk the aisle</a:t>
+              <a:t>Four looks, three seating layouts, instantly.</a:t>
             </a:r>
             <a:endParaRPr lang="en-US" sz="1400" dirty="0"/>
           </a:p>
@@ -7022,14 +7661,94 @@
       </p:sp>
       <p:sp>
         <p:nvSpPr>
-          <p:cNvPr id="8" name="Text 4"/>
+          <p:cNvPr id="13" name="feat-2"/>
+          <p:cNvSpPr/>
+          <p:nvPr/>
+        </p:nvSpPr>
+        <p:spPr>
+          <a:xfrm>
+            <a:off x="6035040" y="1280160"/>
+            <a:ext cx="2560320" cy="1463040"/>
+          </a:xfrm>
+          <a:prstGeom prst="roundRect">
+            <a:avLst>
+              <a:gd name="adj" fmla="val 8750"/>
+            </a:avLst>
+          </a:prstGeom>
+          <a:solidFill>
+            <a:srgbClr val="FFFFFF">
+              <a:alpha val="10000"/>
+            </a:srgbClr>
+          </a:solidFill>
+          <a:ln w="9525">
+            <a:solidFill>
+              <a:srgbClr val="E9C978">
+                <a:alpha val="55000"/>
+              </a:srgbClr>
+            </a:solidFill>
+            <a:prstDash val="solid"/>
+          </a:ln>
+        </p:spPr>
+      </p:sp>
+      <p:sp>
+        <p:nvSpPr>
+          <p:cNvPr id="14" name="icon-bg-feat-2"/>
+          <p:cNvSpPr/>
+          <p:nvPr/>
+        </p:nvSpPr>
+        <p:spPr>
+          <a:xfrm>
+            <a:off x="6217920" y="1463040"/>
+            <a:ext cx="502920" cy="502920"/>
+          </a:xfrm>
+          <a:prstGeom prst="ellipse">
+            <a:avLst/>
+          </a:prstGeom>
+          <a:solidFill>
+            <a:srgbClr val="3AA68A"/>
+          </a:solidFill>
+          <a:ln w="12700">
+            <a:solidFill>
+              <a:srgbClr val="3AA68A"/>
+            </a:solidFill>
+            <a:prstDash val="solid"/>
+          </a:ln>
+        </p:spPr>
+      </p:sp>
+      <p:pic>
+        <p:nvPicPr>
+          <p:cNvPr id="15" name="icon-feat-2" descr="feat-2">    </p:cNvPr>
+          <p:cNvPicPr>
+            <a:picLocks noChangeAspect="1"/>
+          </p:cNvPicPr>
+          <p:nvPr/>
+        </p:nvPicPr>
+        <p:blipFill>
+          <a:blip r:embed="rId3"/>
+          <a:stretch>
+            <a:fillRect/>
+          </a:stretch>
+        </p:blipFill>
+        <p:spPr>
+          <a:xfrm>
+            <a:off x="6353708" y="1598828"/>
+            <a:ext cx="231343" cy="231343"/>
+          </a:xfrm>
+          <a:prstGeom prst="rect">
+            <a:avLst/>
+          </a:prstGeom>
+        </p:spPr>
+      </p:pic>
+      <p:sp>
+        <p:nvSpPr>
+          <p:cNvPr id="16" name="Text 11"/>
           <p:cNvSpPr txBox="1"/>
           <p:nvPr/>
         </p:nvSpPr>
         <p:spPr>
           <a:xfrm>
-            <a:off x="5440680" y="4480560"/>
-            <a:ext cx="3154680" cy="274320"/>
+            <a:off x="6858000" y="1463040"/>
+            <a:ext cx="1645920" cy="502920"/>
           </a:xfrm>
           <a:prstGeom prst="rect">
             <a:avLst/>
@@ -7045,17 +7764,530 @@
               <a:buNone/>
             </a:pPr>
             <a:r>
-              <a:rPr lang="en-US" sz="1300" b="1" dirty="0">
-                <a:solidFill>
-                  <a:srgbClr val="E9C978"/>
+              <a:rPr lang="en-US" sz="1600" b="1" dirty="0">
+                <a:solidFill>
+                  <a:srgbClr val="FFFFFF"/>
+                </a:solidFill>
+                <a:latin typeface="Cambria" pitchFamily="34" charset="0"/>
+                <a:ea typeface="Cambria" pitchFamily="34" charset="-122"/>
+                <a:cs typeface="Cambria" pitchFamily="34" charset="-120"/>
+              </a:rPr>
+              <a:t>Capacity check</a:t>
+            </a:r>
+            <a:endParaRPr lang="en-US" sz="1600" dirty="0"/>
+          </a:p>
+        </p:txBody>
+      </p:sp>
+      <p:sp>
+        <p:nvSpPr>
+          <p:cNvPr id="17" name="Text 12"/>
+          <p:cNvSpPr txBox="1"/>
+          <p:nvPr/>
+        </p:nvSpPr>
+        <p:spPr>
+          <a:xfrm>
+            <a:off x="6217920" y="2103120"/>
+            <a:ext cx="2194560" cy="548640"/>
+          </a:xfrm>
+          <a:prstGeom prst="rect">
+            <a:avLst/>
+          </a:prstGeom>
+          <a:noFill/>
+          <a:ln/>
+        </p:spPr>
+        <p:txBody>
+          <a:bodyPr wrap="square" lIns="0" tIns="0" rIns="0" bIns="0" rtlCol="0" anchor="t"/>
+          <a:lstStyle/>
+          <a:p>
+            <a:pPr indent="0" marL="0">
+              <a:buNone/>
+            </a:pPr>
+            <a:r>
+              <a:rPr lang="en-US" sz="1400" dirty="0">
+                <a:solidFill>
+                  <a:srgbClr val="FFFFFF"/>
                 </a:solidFill>
                 <a:latin typeface="Calibri" pitchFamily="34" charset="0"/>
                 <a:ea typeface="Calibri" pitchFamily="34" charset="-122"/>
                 <a:cs typeface="Calibri" pitchFamily="34" charset="-120"/>
               </a:rPr>
-              <a:t>Live budget — updates with every change</a:t>
+              <a:t>Warns when guests will not fit the hall.</a:t>
             </a:r>
-            <a:endParaRPr lang="en-US" sz="1300" dirty="0"/>
+            <a:endParaRPr lang="en-US" sz="1400" dirty="0"/>
+          </a:p>
+        </p:txBody>
+      </p:sp>
+      <p:sp>
+        <p:nvSpPr>
+          <p:cNvPr id="18" name="feat-3"/>
+          <p:cNvSpPr/>
+          <p:nvPr/>
+        </p:nvSpPr>
+        <p:spPr>
+          <a:xfrm>
+            <a:off x="548640" y="2926080"/>
+            <a:ext cx="2560320" cy="1463040"/>
+          </a:xfrm>
+          <a:prstGeom prst="roundRect">
+            <a:avLst>
+              <a:gd name="adj" fmla="val 8750"/>
+            </a:avLst>
+          </a:prstGeom>
+          <a:solidFill>
+            <a:srgbClr val="FFFFFF">
+              <a:alpha val="10000"/>
+            </a:srgbClr>
+          </a:solidFill>
+          <a:ln w="9525">
+            <a:solidFill>
+              <a:srgbClr val="E9C978">
+                <a:alpha val="55000"/>
+              </a:srgbClr>
+            </a:solidFill>
+            <a:prstDash val="solid"/>
+          </a:ln>
+        </p:spPr>
+      </p:sp>
+      <p:sp>
+        <p:nvSpPr>
+          <p:cNvPr id="19" name="icon-bg-feat-3"/>
+          <p:cNvSpPr/>
+          <p:nvPr/>
+        </p:nvSpPr>
+        <p:spPr>
+          <a:xfrm>
+            <a:off x="731520" y="3108960"/>
+            <a:ext cx="502920" cy="502920"/>
+          </a:xfrm>
+          <a:prstGeom prst="ellipse">
+            <a:avLst/>
+          </a:prstGeom>
+          <a:solidFill>
+            <a:srgbClr val="8B5CF6"/>
+          </a:solidFill>
+          <a:ln w="12700">
+            <a:solidFill>
+              <a:srgbClr val="8B5CF6"/>
+            </a:solidFill>
+            <a:prstDash val="solid"/>
+          </a:ln>
+        </p:spPr>
+      </p:sp>
+      <p:pic>
+        <p:nvPicPr>
+          <p:cNvPr id="20" name="icon-feat-3" descr="feat-3">    </p:cNvPr>
+          <p:cNvPicPr>
+            <a:picLocks noChangeAspect="1"/>
+          </p:cNvPicPr>
+          <p:nvPr/>
+        </p:nvPicPr>
+        <p:blipFill>
+          <a:blip r:embed="rId4"/>
+          <a:stretch>
+            <a:fillRect/>
+          </a:stretch>
+        </p:blipFill>
+        <p:spPr>
+          <a:xfrm>
+            <a:off x="867308" y="3244748"/>
+            <a:ext cx="231343" cy="231343"/>
+          </a:xfrm>
+          <a:prstGeom prst="rect">
+            <a:avLst/>
+          </a:prstGeom>
+        </p:spPr>
+      </p:pic>
+      <p:sp>
+        <p:nvSpPr>
+          <p:cNvPr id="21" name="Text 15"/>
+          <p:cNvSpPr txBox="1"/>
+          <p:nvPr/>
+        </p:nvSpPr>
+        <p:spPr>
+          <a:xfrm>
+            <a:off x="1371600" y="3108960"/>
+            <a:ext cx="1645920" cy="502920"/>
+          </a:xfrm>
+          <a:prstGeom prst="rect">
+            <a:avLst/>
+          </a:prstGeom>
+          <a:noFill/>
+          <a:ln/>
+        </p:spPr>
+        <p:txBody>
+          <a:bodyPr wrap="square" lIns="0" tIns="0" rIns="0" bIns="0" rtlCol="0" anchor="ctr"/>
+          <a:lstStyle/>
+          <a:p>
+            <a:pPr indent="0" marL="0">
+              <a:buNone/>
+            </a:pPr>
+            <a:r>
+              <a:rPr lang="en-US" sz="1600" b="1" dirty="0">
+                <a:solidFill>
+                  <a:srgbClr val="FFFFFF"/>
+                </a:solidFill>
+                <a:latin typeface="Cambria" pitchFamily="34" charset="0"/>
+                <a:ea typeface="Cambria" pitchFamily="34" charset="-122"/>
+                <a:cs typeface="Cambria" pitchFamily="34" charset="-120"/>
+              </a:rPr>
+              <a:t>VR walkthrough</a:t>
+            </a:r>
+            <a:endParaRPr lang="en-US" sz="1600" dirty="0"/>
+          </a:p>
+        </p:txBody>
+      </p:sp>
+      <p:sp>
+        <p:nvSpPr>
+          <p:cNvPr id="22" name="Text 16"/>
+          <p:cNvSpPr txBox="1"/>
+          <p:nvPr/>
+        </p:nvSpPr>
+        <p:spPr>
+          <a:xfrm>
+            <a:off x="731520" y="3749040"/>
+            <a:ext cx="2194560" cy="548640"/>
+          </a:xfrm>
+          <a:prstGeom prst="rect">
+            <a:avLst/>
+          </a:prstGeom>
+          <a:noFill/>
+          <a:ln/>
+        </p:spPr>
+        <p:txBody>
+          <a:bodyPr wrap="square" lIns="0" tIns="0" rIns="0" bIns="0" rtlCol="0" anchor="t"/>
+          <a:lstStyle/>
+          <a:p>
+            <a:pPr indent="0" marL="0">
+              <a:buNone/>
+            </a:pPr>
+            <a:r>
+              <a:rPr lang="en-US" sz="1400" dirty="0">
+                <a:solidFill>
+                  <a:srgbClr val="FFFFFF"/>
+                </a:solidFill>
+                <a:latin typeface="Calibri" pitchFamily="34" charset="0"/>
+                <a:ea typeface="Calibri" pitchFamily="34" charset="-122"/>
+                <a:cs typeface="Calibri" pitchFamily="34" charset="-120"/>
+              </a:rPr>
+              <a:t>Walk the aisle before a rupee is spent.</a:t>
+            </a:r>
+            <a:endParaRPr lang="en-US" sz="1400" dirty="0"/>
+          </a:p>
+        </p:txBody>
+      </p:sp>
+      <p:sp>
+        <p:nvSpPr>
+          <p:cNvPr id="23" name="feat-4"/>
+          <p:cNvSpPr/>
+          <p:nvPr/>
+        </p:nvSpPr>
+        <p:spPr>
+          <a:xfrm>
+            <a:off x="3291840" y="2926080"/>
+            <a:ext cx="2560320" cy="1463040"/>
+          </a:xfrm>
+          <a:prstGeom prst="roundRect">
+            <a:avLst>
+              <a:gd name="adj" fmla="val 8750"/>
+            </a:avLst>
+          </a:prstGeom>
+          <a:solidFill>
+            <a:srgbClr val="FFFFFF">
+              <a:alpha val="10000"/>
+            </a:srgbClr>
+          </a:solidFill>
+          <a:ln w="9525">
+            <a:solidFill>
+              <a:srgbClr val="E9C978">
+                <a:alpha val="55000"/>
+              </a:srgbClr>
+            </a:solidFill>
+            <a:prstDash val="solid"/>
+          </a:ln>
+        </p:spPr>
+      </p:sp>
+      <p:sp>
+        <p:nvSpPr>
+          <p:cNvPr id="24" name="icon-bg-feat-4"/>
+          <p:cNvSpPr/>
+          <p:nvPr/>
+        </p:nvSpPr>
+        <p:spPr>
+          <a:xfrm>
+            <a:off x="3474720" y="3108960"/>
+            <a:ext cx="502920" cy="502920"/>
+          </a:xfrm>
+          <a:prstGeom prst="ellipse">
+            <a:avLst/>
+          </a:prstGeom>
+          <a:solidFill>
+            <a:srgbClr val="B98A2E"/>
+          </a:solidFill>
+          <a:ln w="12700">
+            <a:solidFill>
+              <a:srgbClr val="B98A2E"/>
+            </a:solidFill>
+            <a:prstDash val="solid"/>
+          </a:ln>
+        </p:spPr>
+      </p:sp>
+      <p:pic>
+        <p:nvPicPr>
+          <p:cNvPr id="25" name="icon-feat-4" descr="feat-4">    </p:cNvPr>
+          <p:cNvPicPr>
+            <a:picLocks noChangeAspect="1"/>
+          </p:cNvPicPr>
+          <p:nvPr/>
+        </p:nvPicPr>
+        <p:blipFill>
+          <a:blip r:embed="rId5"/>
+          <a:stretch>
+            <a:fillRect/>
+          </a:stretch>
+        </p:blipFill>
+        <p:spPr>
+          <a:xfrm>
+            <a:off x="3610508" y="3244748"/>
+            <a:ext cx="231343" cy="231343"/>
+          </a:xfrm>
+          <a:prstGeom prst="rect">
+            <a:avLst/>
+          </a:prstGeom>
+        </p:spPr>
+      </p:pic>
+      <p:sp>
+        <p:nvSpPr>
+          <p:cNvPr id="26" name="Text 19"/>
+          <p:cNvSpPr txBox="1"/>
+          <p:nvPr/>
+        </p:nvSpPr>
+        <p:spPr>
+          <a:xfrm>
+            <a:off x="4114800" y="3108960"/>
+            <a:ext cx="1645920" cy="502920"/>
+          </a:xfrm>
+          <a:prstGeom prst="rect">
+            <a:avLst/>
+          </a:prstGeom>
+          <a:noFill/>
+          <a:ln/>
+        </p:spPr>
+        <p:txBody>
+          <a:bodyPr wrap="square" lIns="0" tIns="0" rIns="0" bIns="0" rtlCol="0" anchor="ctr"/>
+          <a:lstStyle/>
+          <a:p>
+            <a:pPr indent="0" marL="0">
+              <a:buNone/>
+            </a:pPr>
+            <a:r>
+              <a:rPr lang="en-US" sz="1600" b="1" dirty="0">
+                <a:solidFill>
+                  <a:srgbClr val="FFFFFF"/>
+                </a:solidFill>
+                <a:latin typeface="Cambria" pitchFamily="34" charset="0"/>
+                <a:ea typeface="Cambria" pitchFamily="34" charset="-122"/>
+                <a:cs typeface="Cambria" pitchFamily="34" charset="-120"/>
+              </a:rPr>
+              <a:t>Live quote</a:t>
+            </a:r>
+            <a:endParaRPr lang="en-US" sz="1600" dirty="0"/>
+          </a:p>
+        </p:txBody>
+      </p:sp>
+      <p:sp>
+        <p:nvSpPr>
+          <p:cNvPr id="27" name="Text 20"/>
+          <p:cNvSpPr txBox="1"/>
+          <p:nvPr/>
+        </p:nvSpPr>
+        <p:spPr>
+          <a:xfrm>
+            <a:off x="3474720" y="3749040"/>
+            <a:ext cx="2194560" cy="548640"/>
+          </a:xfrm>
+          <a:prstGeom prst="rect">
+            <a:avLst/>
+          </a:prstGeom>
+          <a:noFill/>
+          <a:ln/>
+        </p:spPr>
+        <p:txBody>
+          <a:bodyPr wrap="square" lIns="0" tIns="0" rIns="0" bIns="0" rtlCol="0" anchor="t"/>
+          <a:lstStyle/>
+          <a:p>
+            <a:pPr indent="0" marL="0">
+              <a:buNone/>
+            </a:pPr>
+            <a:r>
+              <a:rPr lang="en-US" sz="1400" dirty="0">
+                <a:solidFill>
+                  <a:srgbClr val="FFFFFF"/>
+                </a:solidFill>
+                <a:latin typeface="Calibri" pitchFamily="34" charset="0"/>
+                <a:ea typeface="Calibri" pitchFamily="34" charset="-122"/>
+                <a:cs typeface="Calibri" pitchFamily="34" charset="-120"/>
+              </a:rPr>
+              <a:t>Quantities and costs from your design.</a:t>
+            </a:r>
+            <a:endParaRPr lang="en-US" sz="1400" dirty="0"/>
+          </a:p>
+        </p:txBody>
+      </p:sp>
+      <p:sp>
+        <p:nvSpPr>
+          <p:cNvPr id="28" name="feat-5"/>
+          <p:cNvSpPr/>
+          <p:nvPr/>
+        </p:nvSpPr>
+        <p:spPr>
+          <a:xfrm>
+            <a:off x="6035040" y="2926080"/>
+            <a:ext cx="2560320" cy="1463040"/>
+          </a:xfrm>
+          <a:prstGeom prst="roundRect">
+            <a:avLst>
+              <a:gd name="adj" fmla="val 8750"/>
+            </a:avLst>
+          </a:prstGeom>
+          <a:solidFill>
+            <a:srgbClr val="FFFFFF">
+              <a:alpha val="10000"/>
+            </a:srgbClr>
+          </a:solidFill>
+          <a:ln w="9525">
+            <a:solidFill>
+              <a:srgbClr val="E9C978">
+                <a:alpha val="55000"/>
+              </a:srgbClr>
+            </a:solidFill>
+            <a:prstDash val="solid"/>
+          </a:ln>
+        </p:spPr>
+      </p:sp>
+      <p:sp>
+        <p:nvSpPr>
+          <p:cNvPr id="29" name="icon-bg-feat-5"/>
+          <p:cNvSpPr/>
+          <p:nvPr/>
+        </p:nvSpPr>
+        <p:spPr>
+          <a:xfrm>
+            <a:off x="6217920" y="3108960"/>
+            <a:ext cx="502920" cy="502920"/>
+          </a:xfrm>
+          <a:prstGeom prst="ellipse">
+            <a:avLst/>
+          </a:prstGeom>
+          <a:solidFill>
+            <a:srgbClr val="5B52E0"/>
+          </a:solidFill>
+          <a:ln w="12700">
+            <a:solidFill>
+              <a:srgbClr val="5B52E0"/>
+            </a:solidFill>
+            <a:prstDash val="solid"/>
+          </a:ln>
+        </p:spPr>
+      </p:sp>
+      <p:pic>
+        <p:nvPicPr>
+          <p:cNvPr id="30" name="icon-feat-5" descr="feat-5">    </p:cNvPr>
+          <p:cNvPicPr>
+            <a:picLocks noChangeAspect="1"/>
+          </p:cNvPicPr>
+          <p:nvPr/>
+        </p:nvPicPr>
+        <p:blipFill>
+          <a:blip r:embed="rId6"/>
+          <a:stretch>
+            <a:fillRect/>
+          </a:stretch>
+        </p:blipFill>
+        <p:spPr>
+          <a:xfrm>
+            <a:off x="6353708" y="3244748"/>
+            <a:ext cx="231343" cy="231343"/>
+          </a:xfrm>
+          <a:prstGeom prst="rect">
+            <a:avLst/>
+          </a:prstGeom>
+        </p:spPr>
+      </p:pic>
+      <p:sp>
+        <p:nvSpPr>
+          <p:cNvPr id="31" name="Text 23"/>
+          <p:cNvSpPr txBox="1"/>
+          <p:nvPr/>
+        </p:nvSpPr>
+        <p:spPr>
+          <a:xfrm>
+            <a:off x="6858000" y="3108960"/>
+            <a:ext cx="1645920" cy="502920"/>
+          </a:xfrm>
+          <a:prstGeom prst="rect">
+            <a:avLst/>
+          </a:prstGeom>
+          <a:noFill/>
+          <a:ln/>
+        </p:spPr>
+        <p:txBody>
+          <a:bodyPr wrap="square" lIns="0" tIns="0" rIns="0" bIns="0" rtlCol="0" anchor="ctr"/>
+          <a:lstStyle/>
+          <a:p>
+            <a:pPr indent="0" marL="0">
+              <a:buNone/>
+            </a:pPr>
+            <a:r>
+              <a:rPr lang="en-US" sz="1600" b="1" dirty="0">
+                <a:solidFill>
+                  <a:srgbClr val="FFFFFF"/>
+                </a:solidFill>
+                <a:latin typeface="Cambria" pitchFamily="34" charset="0"/>
+                <a:ea typeface="Cambria" pitchFamily="34" charset="-122"/>
+                <a:cs typeface="Cambria" pitchFamily="34" charset="-120"/>
+              </a:rPr>
+              <a:t>Planner tools</a:t>
+            </a:r>
+            <a:endParaRPr lang="en-US" sz="1600" dirty="0"/>
+          </a:p>
+        </p:txBody>
+      </p:sp>
+      <p:sp>
+        <p:nvSpPr>
+          <p:cNvPr id="32" name="Text 24"/>
+          <p:cNvSpPr txBox="1"/>
+          <p:nvPr/>
+        </p:nvSpPr>
+        <p:spPr>
+          <a:xfrm>
+            <a:off x="6217920" y="3749040"/>
+            <a:ext cx="2194560" cy="548640"/>
+          </a:xfrm>
+          <a:prstGeom prst="rect">
+            <a:avLst/>
+          </a:prstGeom>
+          <a:noFill/>
+          <a:ln/>
+        </p:spPr>
+        <p:txBody>
+          <a:bodyPr wrap="square" lIns="0" tIns="0" rIns="0" bIns="0" rtlCol="0" anchor="t"/>
+          <a:lstStyle/>
+          <a:p>
+            <a:pPr indent="0" marL="0">
+              <a:buNone/>
+            </a:pPr>
+            <a:r>
+              <a:rPr lang="en-US" sz="1400" dirty="0">
+                <a:solidFill>
+                  <a:srgbClr val="FFFFFF"/>
+                </a:solidFill>
+                <a:latin typeface="Calibri" pitchFamily="34" charset="0"/>
+                <a:ea typeface="Calibri" pitchFamily="34" charset="-122"/>
+                <a:cs typeface="Calibri" pitchFamily="34" charset="-120"/>
+              </a:rPr>
+              <a:t>Client pipeline, markup, share links.</a:t>
+            </a:r>
+            <a:endParaRPr lang="en-US" sz="1400" dirty="0"/>
           </a:p>
         </p:txBody>
       </p:sp>
@@ -7168,54 +8400,32 @@
           </a:p>
         </p:txBody>
       </p:sp>
-      <p:pic>
-        <p:nvPicPr>
-          <p:cNvPr id="3" name="look-0" descr="Royal Pastel theme">    </p:cNvPr>
-          <p:cNvPicPr>
-            <a:picLocks noChangeAspect="1"/>
-          </p:cNvPicPr>
-          <p:nvPr/>
-        </p:nvPicPr>
-        <p:blipFill>
-          <a:blip r:embed="rId1"/>
-          <a:stretch>
-            <a:fillRect/>
-          </a:stretch>
-        </p:blipFill>
+      <p:sp>
+        <p:nvSpPr>
+          <p:cNvPr id="3" name="look-0"/>
+          <p:cNvSpPr/>
+          <p:nvPr/>
+        </p:nvSpPr>
         <p:spPr>
           <a:xfrm>
             <a:off x="548640" y="1280160"/>
-            <a:ext cx="2743200" cy="1706880"/>
-          </a:xfrm>
-          <a:prstGeom prst="rect">
-            <a:avLst/>
-          </a:prstGeom>
-        </p:spPr>
-      </p:pic>
-      <p:sp>
-        <p:nvSpPr>
-          <p:cNvPr id="4" name="chip-bg-0"/>
-          <p:cNvSpPr/>
-          <p:nvPr/>
-        </p:nvSpPr>
-        <p:spPr>
-          <a:xfrm>
-            <a:off x="658368" y="2606040"/>
-            <a:ext cx="1783080" cy="292608"/>
+            <a:ext cx="2743200" cy="1554480"/>
           </a:xfrm>
           <a:prstGeom prst="roundRect">
             <a:avLst>
-              <a:gd name="adj" fmla="val 50000"/>
+              <a:gd name="adj" fmla="val 8235"/>
             </a:avLst>
           </a:prstGeom>
           <a:solidFill>
-            <a:srgbClr val="1B1033">
-              <a:alpha val="85000"/>
+            <a:srgbClr val="FFFFFF">
+              <a:alpha val="10000"/>
             </a:srgbClr>
           </a:solidFill>
           <a:ln w="9525">
             <a:solidFill>
-              <a:srgbClr val="E9C978"/>
+              <a:srgbClr val="E9C978">
+                <a:alpha val="55000"/>
+              </a:srgbClr>
             </a:solidFill>
             <a:prstDash val="solid"/>
           </a:ln>
@@ -7223,14 +8433,122 @@
       </p:sp>
       <p:sp>
         <p:nvSpPr>
-          <p:cNvPr id="5" name="Text 2"/>
+          <p:cNvPr id="4" name="swatch-0-0"/>
+          <p:cNvSpPr/>
+          <p:nvPr/>
+        </p:nvSpPr>
+        <p:spPr>
+          <a:xfrm>
+            <a:off x="777240" y="1508760"/>
+            <a:ext cx="457200" cy="457200"/>
+          </a:xfrm>
+          <a:prstGeom prst="ellipse">
+            <a:avLst/>
+          </a:prstGeom>
+          <a:solidFill>
+            <a:srgbClr val="F4BCCB"/>
+          </a:solidFill>
+          <a:ln w="19050">
+            <a:solidFill>
+              <a:srgbClr val="FFFFFF">
+                <a:alpha val="60000"/>
+              </a:srgbClr>
+            </a:solidFill>
+            <a:prstDash val="solid"/>
+          </a:ln>
+        </p:spPr>
+      </p:sp>
+      <p:sp>
+        <p:nvSpPr>
+          <p:cNvPr id="5" name="swatch-0-1"/>
+          <p:cNvSpPr/>
+          <p:nvPr/>
+        </p:nvSpPr>
+        <p:spPr>
+          <a:xfrm>
+            <a:off x="1344168" y="1508760"/>
+            <a:ext cx="457200" cy="457200"/>
+          </a:xfrm>
+          <a:prstGeom prst="ellipse">
+            <a:avLst/>
+          </a:prstGeom>
+          <a:solidFill>
+            <a:srgbClr val="FFF3EA"/>
+          </a:solidFill>
+          <a:ln w="19050">
+            <a:solidFill>
+              <a:srgbClr val="FFFFFF">
+                <a:alpha val="60000"/>
+              </a:srgbClr>
+            </a:solidFill>
+            <a:prstDash val="solid"/>
+          </a:ln>
+        </p:spPr>
+      </p:sp>
+      <p:sp>
+        <p:nvSpPr>
+          <p:cNvPr id="6" name="swatch-0-2"/>
+          <p:cNvSpPr/>
+          <p:nvPr/>
+        </p:nvSpPr>
+        <p:spPr>
+          <a:xfrm>
+            <a:off x="1911096" y="1508760"/>
+            <a:ext cx="457200" cy="457200"/>
+          </a:xfrm>
+          <a:prstGeom prst="ellipse">
+            <a:avLst/>
+          </a:prstGeom>
+          <a:solidFill>
+            <a:srgbClr val="E9C978"/>
+          </a:solidFill>
+          <a:ln w="19050">
+            <a:solidFill>
+              <a:srgbClr val="FFFFFF">
+                <a:alpha val="60000"/>
+              </a:srgbClr>
+            </a:solidFill>
+            <a:prstDash val="solid"/>
+          </a:ln>
+        </p:spPr>
+      </p:sp>
+      <p:sp>
+        <p:nvSpPr>
+          <p:cNvPr id="7" name="swatch-0-3"/>
+          <p:cNvSpPr/>
+          <p:nvPr/>
+        </p:nvSpPr>
+        <p:spPr>
+          <a:xfrm>
+            <a:off x="2478024" y="1508760"/>
+            <a:ext cx="457200" cy="457200"/>
+          </a:xfrm>
+          <a:prstGeom prst="ellipse">
+            <a:avLst/>
+          </a:prstGeom>
+          <a:solidFill>
+            <a:srgbClr val="F4A6B8"/>
+          </a:solidFill>
+          <a:ln w="19050">
+            <a:solidFill>
+              <a:srgbClr val="FFFFFF">
+                <a:alpha val="60000"/>
+              </a:srgbClr>
+            </a:solidFill>
+            <a:prstDash val="solid"/>
+          </a:ln>
+        </p:spPr>
+      </p:sp>
+      <p:sp>
+        <p:nvSpPr>
+          <p:cNvPr id="8" name="Text 6"/>
           <p:cNvSpPr txBox="1"/>
           <p:nvPr/>
         </p:nvSpPr>
         <p:spPr>
           <a:xfrm>
-            <a:off x="658368" y="2606040"/>
-            <a:ext cx="1783080" cy="292608"/>
+            <a:off x="777240" y="2103120"/>
+            <a:ext cx="2377440" cy="365760"/>
           </a:xfrm>
           <a:prstGeom prst="rect">
             <a:avLst/>
@@ -7242,11 +8560,50 @@
           <a:bodyPr wrap="square" lIns="0" tIns="0" rIns="0" bIns="0" rtlCol="0" anchor="ctr"/>
           <a:lstStyle/>
           <a:p>
-            <a:pPr algn="ctr" indent="0" marL="0">
+            <a:pPr indent="0" marL="0">
               <a:buNone/>
             </a:pPr>
             <a:r>
-              <a:rPr lang="en-US" sz="1200" b="1" dirty="0">
+              <a:rPr lang="en-US" sz="1800" b="1" dirty="0">
+                <a:solidFill>
+                  <a:srgbClr val="FFFFFF"/>
+                </a:solidFill>
+                <a:latin typeface="Cambria" pitchFamily="34" charset="0"/>
+                <a:ea typeface="Cambria" pitchFamily="34" charset="-122"/>
+                <a:cs typeface="Cambria" pitchFamily="34" charset="-120"/>
+              </a:rPr>
+              <a:t>Royal Pastel</a:t>
+            </a:r>
+            <a:endParaRPr lang="en-US" sz="1800" dirty="0"/>
+          </a:p>
+        </p:txBody>
+      </p:sp>
+      <p:sp>
+        <p:nvSpPr>
+          <p:cNvPr id="9" name="Text 7"/>
+          <p:cNvSpPr txBox="1"/>
+          <p:nvPr/>
+        </p:nvSpPr>
+        <p:spPr>
+          <a:xfrm>
+            <a:off x="777240" y="2468880"/>
+            <a:ext cx="2377440" cy="274320"/>
+          </a:xfrm>
+          <a:prstGeom prst="rect">
+            <a:avLst/>
+          </a:prstGeom>
+          <a:noFill/>
+          <a:ln/>
+        </p:spPr>
+        <p:txBody>
+          <a:bodyPr wrap="square" lIns="0" tIns="0" rIns="0" bIns="0" rtlCol="0" anchor="ctr"/>
+          <a:lstStyle/>
+          <a:p>
+            <a:pPr indent="0" marL="0">
+              <a:buNone/>
+            </a:pPr>
+            <a:r>
+              <a:rPr lang="en-US" sz="1300" dirty="0">
                 <a:solidFill>
                   <a:srgbClr val="FFFFFF"/>
                 </a:solidFill>
@@ -7254,60 +8611,38 @@
                 <a:ea typeface="Calibri" pitchFamily="34" charset="-122"/>
                 <a:cs typeface="Calibri" pitchFamily="34" charset="-120"/>
               </a:rPr>
-              <a:t>Royal Pastel</a:t>
+              <a:t>Soft, romantic, ivory &amp; blush</a:t>
             </a:r>
-            <a:endParaRPr lang="en-US" sz="1200" dirty="0"/>
-          </a:p>
-        </p:txBody>
-      </p:sp>
-      <p:pic>
-        <p:nvPicPr>
-          <p:cNvPr id="6" name="look-1" descr="Emerald Heritage theme">    </p:cNvPr>
-          <p:cNvPicPr>
-            <a:picLocks noChangeAspect="1"/>
-          </p:cNvPicPr>
-          <p:nvPr/>
-        </p:nvPicPr>
-        <p:blipFill>
-          <a:blip r:embed="rId2"/>
-          <a:stretch>
-            <a:fillRect/>
-          </a:stretch>
-        </p:blipFill>
+            <a:endParaRPr lang="en-US" sz="1300" dirty="0"/>
+          </a:p>
+        </p:txBody>
+      </p:sp>
+      <p:sp>
+        <p:nvSpPr>
+          <p:cNvPr id="10" name="look-1"/>
+          <p:cNvSpPr/>
+          <p:nvPr/>
+        </p:nvSpPr>
         <p:spPr>
           <a:xfrm>
             <a:off x="3429000" y="1280160"/>
-            <a:ext cx="2743200" cy="1706880"/>
-          </a:xfrm>
-          <a:prstGeom prst="rect">
-            <a:avLst/>
-          </a:prstGeom>
-        </p:spPr>
-      </p:pic>
-      <p:sp>
-        <p:nvSpPr>
-          <p:cNvPr id="7" name="chip-bg-1"/>
-          <p:cNvSpPr/>
-          <p:nvPr/>
-        </p:nvSpPr>
-        <p:spPr>
-          <a:xfrm>
-            <a:off x="3538728" y="2606040"/>
-            <a:ext cx="1783080" cy="292608"/>
+            <a:ext cx="2743200" cy="1554480"/>
           </a:xfrm>
           <a:prstGeom prst="roundRect">
             <a:avLst>
-              <a:gd name="adj" fmla="val 50000"/>
+              <a:gd name="adj" fmla="val 8235"/>
             </a:avLst>
           </a:prstGeom>
           <a:solidFill>
-            <a:srgbClr val="1B1033">
-              <a:alpha val="85000"/>
+            <a:srgbClr val="FFFFFF">
+              <a:alpha val="10000"/>
             </a:srgbClr>
           </a:solidFill>
           <a:ln w="9525">
             <a:solidFill>
-              <a:srgbClr val="E9C978"/>
+              <a:srgbClr val="E9C978">
+                <a:alpha val="55000"/>
+              </a:srgbClr>
             </a:solidFill>
             <a:prstDash val="solid"/>
           </a:ln>
@@ -7315,14 +8650,122 @@
       </p:sp>
       <p:sp>
         <p:nvSpPr>
-          <p:cNvPr id="8" name="Text 4"/>
+          <p:cNvPr id="11" name="swatch-1-0"/>
+          <p:cNvSpPr/>
+          <p:nvPr/>
+        </p:nvSpPr>
+        <p:spPr>
+          <a:xfrm>
+            <a:off x="3657600" y="1508760"/>
+            <a:ext cx="457200" cy="457200"/>
+          </a:xfrm>
+          <a:prstGeom prst="ellipse">
+            <a:avLst/>
+          </a:prstGeom>
+          <a:solidFill>
+            <a:srgbClr val="1F7A58"/>
+          </a:solidFill>
+          <a:ln w="19050">
+            <a:solidFill>
+              <a:srgbClr val="FFFFFF">
+                <a:alpha val="60000"/>
+              </a:srgbClr>
+            </a:solidFill>
+            <a:prstDash val="solid"/>
+          </a:ln>
+        </p:spPr>
+      </p:sp>
+      <p:sp>
+        <p:nvSpPr>
+          <p:cNvPr id="12" name="swatch-1-1"/>
+          <p:cNvSpPr/>
+          <p:nvPr/>
+        </p:nvSpPr>
+        <p:spPr>
+          <a:xfrm>
+            <a:off x="4224528" y="1508760"/>
+            <a:ext cx="457200" cy="457200"/>
+          </a:xfrm>
+          <a:prstGeom prst="ellipse">
+            <a:avLst/>
+          </a:prstGeom>
+          <a:solidFill>
+            <a:srgbClr val="F4EFDC"/>
+          </a:solidFill>
+          <a:ln w="19050">
+            <a:solidFill>
+              <a:srgbClr val="FFFFFF">
+                <a:alpha val="60000"/>
+              </a:srgbClr>
+            </a:solidFill>
+            <a:prstDash val="solid"/>
+          </a:ln>
+        </p:spPr>
+      </p:sp>
+      <p:sp>
+        <p:nvSpPr>
+          <p:cNvPr id="13" name="swatch-1-2"/>
+          <p:cNvSpPr/>
+          <p:nvPr/>
+        </p:nvSpPr>
+        <p:spPr>
+          <a:xfrm>
+            <a:off x="4791456" y="1508760"/>
+            <a:ext cx="457200" cy="457200"/>
+          </a:xfrm>
+          <a:prstGeom prst="ellipse">
+            <a:avLst/>
+          </a:prstGeom>
+          <a:solidFill>
+            <a:srgbClr val="F5D76E"/>
+          </a:solidFill>
+          <a:ln w="19050">
+            <a:solidFill>
+              <a:srgbClr val="FFFFFF">
+                <a:alpha val="60000"/>
+              </a:srgbClr>
+            </a:solidFill>
+            <a:prstDash val="solid"/>
+          </a:ln>
+        </p:spPr>
+      </p:sp>
+      <p:sp>
+        <p:nvSpPr>
+          <p:cNvPr id="14" name="swatch-1-3"/>
+          <p:cNvSpPr/>
+          <p:nvPr/>
+        </p:nvSpPr>
+        <p:spPr>
+          <a:xfrm>
+            <a:off x="5358384" y="1508760"/>
+            <a:ext cx="457200" cy="457200"/>
+          </a:xfrm>
+          <a:prstGeom prst="ellipse">
+            <a:avLst/>
+          </a:prstGeom>
+          <a:solidFill>
+            <a:srgbClr val="8FD1AC"/>
+          </a:solidFill>
+          <a:ln w="19050">
+            <a:solidFill>
+              <a:srgbClr val="FFFFFF">
+                <a:alpha val="60000"/>
+              </a:srgbClr>
+            </a:solidFill>
+            <a:prstDash val="solid"/>
+          </a:ln>
+        </p:spPr>
+      </p:sp>
+      <p:sp>
+        <p:nvSpPr>
+          <p:cNvPr id="15" name="Text 13"/>
           <p:cNvSpPr txBox="1"/>
           <p:nvPr/>
         </p:nvSpPr>
         <p:spPr>
           <a:xfrm>
-            <a:off x="3538728" y="2606040"/>
-            <a:ext cx="1783080" cy="292608"/>
+            <a:off x="3657600" y="2103120"/>
+            <a:ext cx="2377440" cy="365760"/>
           </a:xfrm>
           <a:prstGeom prst="rect">
             <a:avLst/>
@@ -7334,11 +8777,50 @@
           <a:bodyPr wrap="square" lIns="0" tIns="0" rIns="0" bIns="0" rtlCol="0" anchor="ctr"/>
           <a:lstStyle/>
           <a:p>
-            <a:pPr algn="ctr" indent="0" marL="0">
+            <a:pPr indent="0" marL="0">
               <a:buNone/>
             </a:pPr>
             <a:r>
-              <a:rPr lang="en-US" sz="1200" b="1" dirty="0">
+              <a:rPr lang="en-US" sz="1800" b="1" dirty="0">
+                <a:solidFill>
+                  <a:srgbClr val="FFFFFF"/>
+                </a:solidFill>
+                <a:latin typeface="Cambria" pitchFamily="34" charset="0"/>
+                <a:ea typeface="Cambria" pitchFamily="34" charset="-122"/>
+                <a:cs typeface="Cambria" pitchFamily="34" charset="-120"/>
+              </a:rPr>
+              <a:t>Emerald Heritage</a:t>
+            </a:r>
+            <a:endParaRPr lang="en-US" sz="1800" dirty="0"/>
+          </a:p>
+        </p:txBody>
+      </p:sp>
+      <p:sp>
+        <p:nvSpPr>
+          <p:cNvPr id="16" name="Text 14"/>
+          <p:cNvSpPr txBox="1"/>
+          <p:nvPr/>
+        </p:nvSpPr>
+        <p:spPr>
+          <a:xfrm>
+            <a:off x="3657600" y="2468880"/>
+            <a:ext cx="2377440" cy="274320"/>
+          </a:xfrm>
+          <a:prstGeom prst="rect">
+            <a:avLst/>
+          </a:prstGeom>
+          <a:noFill/>
+          <a:ln/>
+        </p:spPr>
+        <p:txBody>
+          <a:bodyPr wrap="square" lIns="0" tIns="0" rIns="0" bIns="0" rtlCol="0" anchor="ctr"/>
+          <a:lstStyle/>
+          <a:p>
+            <a:pPr indent="0" marL="0">
+              <a:buNone/>
+            </a:pPr>
+            <a:r>
+              <a:rPr lang="en-US" sz="1300" dirty="0">
                 <a:solidFill>
                   <a:srgbClr val="FFFFFF"/>
                 </a:solidFill>
@@ -7346,60 +8828,38 @@
                 <a:ea typeface="Calibri" pitchFamily="34" charset="-122"/>
                 <a:cs typeface="Calibri" pitchFamily="34" charset="-120"/>
               </a:rPr>
-              <a:t>Emerald Heritage</a:t>
+              <a:t>Classic, regal, green &amp; gold</a:t>
             </a:r>
-            <a:endParaRPr lang="en-US" sz="1200" dirty="0"/>
-          </a:p>
-        </p:txBody>
-      </p:sp>
-      <p:pic>
-        <p:nvPicPr>
-          <p:cNvPr id="9" name="look-2" descr="Crimson Maharaja theme">    </p:cNvPr>
-          <p:cNvPicPr>
-            <a:picLocks noChangeAspect="1"/>
-          </p:cNvPicPr>
-          <p:nvPr/>
-        </p:nvPicPr>
-        <p:blipFill>
-          <a:blip r:embed="rId3"/>
-          <a:stretch>
-            <a:fillRect/>
-          </a:stretch>
-        </p:blipFill>
-        <p:spPr>
-          <a:xfrm>
-            <a:off x="548640" y="3108960"/>
-            <a:ext cx="2743200" cy="1706880"/>
-          </a:xfrm>
-          <a:prstGeom prst="rect">
-            <a:avLst/>
-          </a:prstGeom>
-        </p:spPr>
-      </p:pic>
-      <p:sp>
-        <p:nvSpPr>
-          <p:cNvPr id="10" name="chip-bg-2"/>
+            <a:endParaRPr lang="en-US" sz="1300" dirty="0"/>
+          </a:p>
+        </p:txBody>
+      </p:sp>
+      <p:sp>
+        <p:nvSpPr>
+          <p:cNvPr id="17" name="look-2"/>
           <p:cNvSpPr/>
           <p:nvPr/>
         </p:nvSpPr>
         <p:spPr>
           <a:xfrm>
-            <a:off x="658368" y="4434840"/>
-            <a:ext cx="1783080" cy="292608"/>
+            <a:off x="548640" y="2971800"/>
+            <a:ext cx="2743200" cy="1554480"/>
           </a:xfrm>
           <a:prstGeom prst="roundRect">
             <a:avLst>
-              <a:gd name="adj" fmla="val 50000"/>
+              <a:gd name="adj" fmla="val 8235"/>
             </a:avLst>
           </a:prstGeom>
           <a:solidFill>
-            <a:srgbClr val="1B1033">
-              <a:alpha val="85000"/>
+            <a:srgbClr val="FFFFFF">
+              <a:alpha val="10000"/>
             </a:srgbClr>
           </a:solidFill>
           <a:ln w="9525">
             <a:solidFill>
-              <a:srgbClr val="E9C978"/>
+              <a:srgbClr val="E9C978">
+                <a:alpha val="55000"/>
+              </a:srgbClr>
             </a:solidFill>
             <a:prstDash val="solid"/>
           </a:ln>
@@ -7407,14 +8867,122 @@
       </p:sp>
       <p:sp>
         <p:nvSpPr>
-          <p:cNvPr id="11" name="Text 6"/>
+          <p:cNvPr id="18" name="swatch-2-0"/>
+          <p:cNvSpPr/>
+          <p:nvPr/>
+        </p:nvSpPr>
+        <p:spPr>
+          <a:xfrm>
+            <a:off x="777240" y="3200400"/>
+            <a:ext cx="457200" cy="457200"/>
+          </a:xfrm>
+          <a:prstGeom prst="ellipse">
+            <a:avLst/>
+          </a:prstGeom>
+          <a:solidFill>
+            <a:srgbClr val="A8182F"/>
+          </a:solidFill>
+          <a:ln w="19050">
+            <a:solidFill>
+              <a:srgbClr val="FFFFFF">
+                <a:alpha val="60000"/>
+              </a:srgbClr>
+            </a:solidFill>
+            <a:prstDash val="solid"/>
+          </a:ln>
+        </p:spPr>
+      </p:sp>
+      <p:sp>
+        <p:nvSpPr>
+          <p:cNvPr id="19" name="swatch-2-1"/>
+          <p:cNvSpPr/>
+          <p:nvPr/>
+        </p:nvSpPr>
+        <p:spPr>
+          <a:xfrm>
+            <a:off x="1344168" y="3200400"/>
+            <a:ext cx="457200" cy="457200"/>
+          </a:xfrm>
+          <a:prstGeom prst="ellipse">
+            <a:avLst/>
+          </a:prstGeom>
+          <a:solidFill>
+            <a:srgbClr val="F2C14E"/>
+          </a:solidFill>
+          <a:ln w="19050">
+            <a:solidFill>
+              <a:srgbClr val="FFFFFF">
+                <a:alpha val="60000"/>
+              </a:srgbClr>
+            </a:solidFill>
+            <a:prstDash val="solid"/>
+          </a:ln>
+        </p:spPr>
+      </p:sp>
+      <p:sp>
+        <p:nvSpPr>
+          <p:cNvPr id="20" name="swatch-2-2"/>
+          <p:cNvSpPr/>
+          <p:nvPr/>
+        </p:nvSpPr>
+        <p:spPr>
+          <a:xfrm>
+            <a:off x="1911096" y="3200400"/>
+            <a:ext cx="457200" cy="457200"/>
+          </a:xfrm>
+          <a:prstGeom prst="ellipse">
+            <a:avLst/>
+          </a:prstGeom>
+          <a:solidFill>
+            <a:srgbClr val="FF8C42"/>
+          </a:solidFill>
+          <a:ln w="19050">
+            <a:solidFill>
+              <a:srgbClr val="FFFFFF">
+                <a:alpha val="60000"/>
+              </a:srgbClr>
+            </a:solidFill>
+            <a:prstDash val="solid"/>
+          </a:ln>
+        </p:spPr>
+      </p:sp>
+      <p:sp>
+        <p:nvSpPr>
+          <p:cNvPr id="21" name="swatch-2-3"/>
+          <p:cNvSpPr/>
+          <p:nvPr/>
+        </p:nvSpPr>
+        <p:spPr>
+          <a:xfrm>
+            <a:off x="2478024" y="3200400"/>
+            <a:ext cx="457200" cy="457200"/>
+          </a:xfrm>
+          <a:prstGeom prst="ellipse">
+            <a:avLst/>
+          </a:prstGeom>
+          <a:solidFill>
+            <a:srgbClr val="D7263D"/>
+          </a:solidFill>
+          <a:ln w="19050">
+            <a:solidFill>
+              <a:srgbClr val="FFFFFF">
+                <a:alpha val="60000"/>
+              </a:srgbClr>
+            </a:solidFill>
+            <a:prstDash val="solid"/>
+          </a:ln>
+        </p:spPr>
+      </p:sp>
+      <p:sp>
+        <p:nvSpPr>
+          <p:cNvPr id="22" name="Text 20"/>
           <p:cNvSpPr txBox="1"/>
           <p:nvPr/>
         </p:nvSpPr>
         <p:spPr>
           <a:xfrm>
-            <a:off x="658368" y="4434840"/>
-            <a:ext cx="1783080" cy="292608"/>
+            <a:off x="777240" y="3794760"/>
+            <a:ext cx="2377440" cy="365760"/>
           </a:xfrm>
           <a:prstGeom prst="rect">
             <a:avLst/>
@@ -7426,11 +8994,50 @@
           <a:bodyPr wrap="square" lIns="0" tIns="0" rIns="0" bIns="0" rtlCol="0" anchor="ctr"/>
           <a:lstStyle/>
           <a:p>
-            <a:pPr algn="ctr" indent="0" marL="0">
+            <a:pPr indent="0" marL="0">
               <a:buNone/>
             </a:pPr>
             <a:r>
-              <a:rPr lang="en-US" sz="1200" b="1" dirty="0">
+              <a:rPr lang="en-US" sz="1800" b="1" dirty="0">
+                <a:solidFill>
+                  <a:srgbClr val="FFFFFF"/>
+                </a:solidFill>
+                <a:latin typeface="Cambria" pitchFamily="34" charset="0"/>
+                <a:ea typeface="Cambria" pitchFamily="34" charset="-122"/>
+                <a:cs typeface="Cambria" pitchFamily="34" charset="-120"/>
+              </a:rPr>
+              <a:t>Crimson Maharaja</a:t>
+            </a:r>
+            <a:endParaRPr lang="en-US" sz="1800" dirty="0"/>
+          </a:p>
+        </p:txBody>
+      </p:sp>
+      <p:sp>
+        <p:nvSpPr>
+          <p:cNvPr id="23" name="Text 21"/>
+          <p:cNvSpPr txBox="1"/>
+          <p:nvPr/>
+        </p:nvSpPr>
+        <p:spPr>
+          <a:xfrm>
+            <a:off x="777240" y="4160520"/>
+            <a:ext cx="2377440" cy="274320"/>
+          </a:xfrm>
+          <a:prstGeom prst="rect">
+            <a:avLst/>
+          </a:prstGeom>
+          <a:noFill/>
+          <a:ln/>
+        </p:spPr>
+        <p:txBody>
+          <a:bodyPr wrap="square" lIns="0" tIns="0" rIns="0" bIns="0" rtlCol="0" anchor="ctr"/>
+          <a:lstStyle/>
+          <a:p>
+            <a:pPr indent="0" marL="0">
+              <a:buNone/>
+            </a:pPr>
+            <a:r>
+              <a:rPr lang="en-US" sz="1300" dirty="0">
                 <a:solidFill>
                   <a:srgbClr val="FFFFFF"/>
                 </a:solidFill>
@@ -7438,60 +9045,38 @@
                 <a:ea typeface="Calibri" pitchFamily="34" charset="-122"/>
                 <a:cs typeface="Calibri" pitchFamily="34" charset="-120"/>
               </a:rPr>
-              <a:t>Crimson Maharaja</a:t>
+              <a:t>Bold, festive, red &amp; gold</a:t>
             </a:r>
-            <a:endParaRPr lang="en-US" sz="1200" dirty="0"/>
-          </a:p>
-        </p:txBody>
-      </p:sp>
-      <p:pic>
-        <p:nvPicPr>
-          <p:cNvPr id="12" name="look-3" descr="Midnight Gala theme">    </p:cNvPr>
-          <p:cNvPicPr>
-            <a:picLocks noChangeAspect="1"/>
-          </p:cNvPicPr>
-          <p:nvPr/>
-        </p:nvPicPr>
-        <p:blipFill>
-          <a:blip r:embed="rId4"/>
-          <a:stretch>
-            <a:fillRect/>
-          </a:stretch>
-        </p:blipFill>
-        <p:spPr>
-          <a:xfrm>
-            <a:off x="3429000" y="3108960"/>
-            <a:ext cx="2743200" cy="1706880"/>
-          </a:xfrm>
-          <a:prstGeom prst="rect">
-            <a:avLst/>
-          </a:prstGeom>
-        </p:spPr>
-      </p:pic>
-      <p:sp>
-        <p:nvSpPr>
-          <p:cNvPr id="13" name="chip-bg-3"/>
+            <a:endParaRPr lang="en-US" sz="1300" dirty="0"/>
+          </a:p>
+        </p:txBody>
+      </p:sp>
+      <p:sp>
+        <p:nvSpPr>
+          <p:cNvPr id="24" name="look-3"/>
           <p:cNvSpPr/>
           <p:nvPr/>
         </p:nvSpPr>
         <p:spPr>
           <a:xfrm>
-            <a:off x="3538728" y="4434840"/>
-            <a:ext cx="1783080" cy="292608"/>
+            <a:off x="3429000" y="2971800"/>
+            <a:ext cx="2743200" cy="1554480"/>
           </a:xfrm>
           <a:prstGeom prst="roundRect">
             <a:avLst>
-              <a:gd name="adj" fmla="val 50000"/>
+              <a:gd name="adj" fmla="val 8235"/>
             </a:avLst>
           </a:prstGeom>
           <a:solidFill>
-            <a:srgbClr val="1B1033">
-              <a:alpha val="85000"/>
+            <a:srgbClr val="FFFFFF">
+              <a:alpha val="10000"/>
             </a:srgbClr>
           </a:solidFill>
           <a:ln w="9525">
             <a:solidFill>
-              <a:srgbClr val="E9C978"/>
+              <a:srgbClr val="E9C978">
+                <a:alpha val="55000"/>
+              </a:srgbClr>
             </a:solidFill>
             <a:prstDash val="solid"/>
           </a:ln>
@@ -7499,14 +9084,122 @@
       </p:sp>
       <p:sp>
         <p:nvSpPr>
-          <p:cNvPr id="14" name="Text 8"/>
+          <p:cNvPr id="25" name="swatch-3-0"/>
+          <p:cNvSpPr/>
+          <p:nvPr/>
+        </p:nvSpPr>
+        <p:spPr>
+          <a:xfrm>
+            <a:off x="3657600" y="3200400"/>
+            <a:ext cx="457200" cy="457200"/>
+          </a:xfrm>
+          <a:prstGeom prst="ellipse">
+            <a:avLst/>
+          </a:prstGeom>
+          <a:solidFill>
+            <a:srgbClr val="2B3A8A"/>
+          </a:solidFill>
+          <a:ln w="19050">
+            <a:solidFill>
+              <a:srgbClr val="FFFFFF">
+                <a:alpha val="60000"/>
+              </a:srgbClr>
+            </a:solidFill>
+            <a:prstDash val="solid"/>
+          </a:ln>
+        </p:spPr>
+      </p:sp>
+      <p:sp>
+        <p:nvSpPr>
+          <p:cNvPr id="26" name="swatch-3-1"/>
+          <p:cNvSpPr/>
+          <p:nvPr/>
+        </p:nvSpPr>
+        <p:spPr>
+          <a:xfrm>
+            <a:off x="4224528" y="3200400"/>
+            <a:ext cx="457200" cy="457200"/>
+          </a:xfrm>
+          <a:prstGeom prst="ellipse">
+            <a:avLst/>
+          </a:prstGeom>
+          <a:solidFill>
+            <a:srgbClr val="E3E9FF"/>
+          </a:solidFill>
+          <a:ln w="19050">
+            <a:solidFill>
+              <a:srgbClr val="FFFFFF">
+                <a:alpha val="60000"/>
+              </a:srgbClr>
+            </a:solidFill>
+            <a:prstDash val="solid"/>
+          </a:ln>
+        </p:spPr>
+      </p:sp>
+      <p:sp>
+        <p:nvSpPr>
+          <p:cNvPr id="27" name="swatch-3-2"/>
+          <p:cNvSpPr/>
+          <p:nvPr/>
+        </p:nvSpPr>
+        <p:spPr>
+          <a:xfrm>
+            <a:off x="4791456" y="3200400"/>
+            <a:ext cx="457200" cy="457200"/>
+          </a:xfrm>
+          <a:prstGeom prst="ellipse">
+            <a:avLst/>
+          </a:prstGeom>
+          <a:solidFill>
+            <a:srgbClr val="B7C7FF"/>
+          </a:solidFill>
+          <a:ln w="19050">
+            <a:solidFill>
+              <a:srgbClr val="FFFFFF">
+                <a:alpha val="60000"/>
+              </a:srgbClr>
+            </a:solidFill>
+            <a:prstDash val="solid"/>
+          </a:ln>
+        </p:spPr>
+      </p:sp>
+      <p:sp>
+        <p:nvSpPr>
+          <p:cNvPr id="28" name="swatch-3-3"/>
+          <p:cNvSpPr/>
+          <p:nvPr/>
+        </p:nvSpPr>
+        <p:spPr>
+          <a:xfrm>
+            <a:off x="5358384" y="3200400"/>
+            <a:ext cx="457200" cy="457200"/>
+          </a:xfrm>
+          <a:prstGeom prst="ellipse">
+            <a:avLst/>
+          </a:prstGeom>
+          <a:solidFill>
+            <a:srgbClr val="E8C872"/>
+          </a:solidFill>
+          <a:ln w="19050">
+            <a:solidFill>
+              <a:srgbClr val="FFFFFF">
+                <a:alpha val="60000"/>
+              </a:srgbClr>
+            </a:solidFill>
+            <a:prstDash val="solid"/>
+          </a:ln>
+        </p:spPr>
+      </p:sp>
+      <p:sp>
+        <p:nvSpPr>
+          <p:cNvPr id="29" name="Text 27"/>
           <p:cNvSpPr txBox="1"/>
           <p:nvPr/>
         </p:nvSpPr>
         <p:spPr>
           <a:xfrm>
-            <a:off x="3538728" y="4434840"/>
-            <a:ext cx="1783080" cy="292608"/>
+            <a:off x="3657600" y="3794760"/>
+            <a:ext cx="2377440" cy="365760"/>
           </a:xfrm>
           <a:prstGeom prst="rect">
             <a:avLst/>
@@ -7518,11 +9211,50 @@
           <a:bodyPr wrap="square" lIns="0" tIns="0" rIns="0" bIns="0" rtlCol="0" anchor="ctr"/>
           <a:lstStyle/>
           <a:p>
-            <a:pPr algn="ctr" indent="0" marL="0">
+            <a:pPr indent="0" marL="0">
               <a:buNone/>
             </a:pPr>
             <a:r>
-              <a:rPr lang="en-US" sz="1200" b="1" dirty="0">
+              <a:rPr lang="en-US" sz="1800" b="1" dirty="0">
+                <a:solidFill>
+                  <a:srgbClr val="FFFFFF"/>
+                </a:solidFill>
+                <a:latin typeface="Cambria" pitchFamily="34" charset="0"/>
+                <a:ea typeface="Cambria" pitchFamily="34" charset="-122"/>
+                <a:cs typeface="Cambria" pitchFamily="34" charset="-120"/>
+              </a:rPr>
+              <a:t>Midnight Gala</a:t>
+            </a:r>
+            <a:endParaRPr lang="en-US" sz="1800" dirty="0"/>
+          </a:p>
+        </p:txBody>
+      </p:sp>
+      <p:sp>
+        <p:nvSpPr>
+          <p:cNvPr id="30" name="Text 28"/>
+          <p:cNvSpPr txBox="1"/>
+          <p:nvPr/>
+        </p:nvSpPr>
+        <p:spPr>
+          <a:xfrm>
+            <a:off x="3657600" y="4160520"/>
+            <a:ext cx="2377440" cy="274320"/>
+          </a:xfrm>
+          <a:prstGeom prst="rect">
+            <a:avLst/>
+          </a:prstGeom>
+          <a:noFill/>
+          <a:ln/>
+        </p:spPr>
+        <p:txBody>
+          <a:bodyPr wrap="square" lIns="0" tIns="0" rIns="0" bIns="0" rtlCol="0" anchor="ctr"/>
+          <a:lstStyle/>
+          <a:p>
+            <a:pPr indent="0" marL="0">
+              <a:buNone/>
+            </a:pPr>
+            <a:r>
+              <a:rPr lang="en-US" sz="1300" dirty="0">
                 <a:solidFill>
                   <a:srgbClr val="FFFFFF"/>
                 </a:solidFill>
@@ -7530,15 +9262,15 @@
                 <a:ea typeface="Calibri" pitchFamily="34" charset="-122"/>
                 <a:cs typeface="Calibri" pitchFamily="34" charset="-120"/>
               </a:rPr>
-              <a:t>Midnight Gala</a:t>
+              <a:t>Modern, elegant, navy &amp; silver</a:t>
             </a:r>
-            <a:endParaRPr lang="en-US" sz="1200" dirty="0"/>
-          </a:p>
-        </p:txBody>
-      </p:sp>
-      <p:sp>
-        <p:nvSpPr>
-          <p:cNvPr id="15" name="Text 9"/>
+            <a:endParaRPr lang="en-US" sz="1300" dirty="0"/>
+          </a:p>
+        </p:txBody>
+      </p:sp>
+      <p:sp>
+        <p:nvSpPr>
+          <p:cNvPr id="31" name="Text 29"/>
           <p:cNvSpPr txBox="1"/>
           <p:nvPr/>
         </p:nvSpPr>
@@ -7577,7 +9309,7 @@
       </p:sp>
       <p:sp>
         <p:nvSpPr>
-          <p:cNvPr id="16" name="Text 10"/>
+          <p:cNvPr id="32" name="Text 30"/>
           <p:cNvSpPr txBox="1"/>
           <p:nvPr/>
         </p:nvSpPr>
@@ -7616,7 +9348,7 @@
       </p:sp>
       <p:sp>
         <p:nvSpPr>
-          <p:cNvPr id="17" name="Text 11"/>
+          <p:cNvPr id="33" name="Text 31"/>
           <p:cNvSpPr txBox="1"/>
           <p:nvPr/>
         </p:nvSpPr>
@@ -7655,7 +9387,7 @@
       </p:sp>
       <p:sp>
         <p:nvSpPr>
-          <p:cNvPr id="18" name="Text 12"/>
+          <p:cNvPr id="34" name="Text 32"/>
           <p:cNvSpPr txBox="1"/>
           <p:nvPr/>
         </p:nvSpPr>
@@ -7694,7 +9426,7 @@
       </p:sp>
       <p:sp>
         <p:nvSpPr>
-          <p:cNvPr id="19" name="Text 13"/>
+          <p:cNvPr id="35" name="Text 33"/>
           <p:cNvSpPr txBox="1"/>
           <p:nvPr/>
         </p:nvSpPr>
@@ -7733,7 +9465,7 @@
       </p:sp>
       <p:sp>
         <p:nvSpPr>
-          <p:cNvPr id="20" name="Text 14"/>
+          <p:cNvPr id="36" name="Text 34"/>
           <p:cNvSpPr txBox="1"/>
           <p:nvPr/>
         </p:nvSpPr>

</xml_diff>